<commit_message>
Updated the presentation PDFs
</commit_message>
<xml_diff>
--- a/Presentation/Neural Network Implementation.pptx
+++ b/Presentation/Neural Network Implementation.pptx
@@ -24,17 +24,18 @@
     <p:sldId id="272" r:id="rId22"/>
     <p:sldId id="273" r:id="rId23"/>
     <p:sldId id="274" r:id="rId24"/>
+    <p:sldId id="275" r:id="rId25"/>
   </p:sldIdLst>
   <p:sldSz cx="18288000" cy="10287000"/>
   <p:notesSz cx="6858000" cy="9144000"/>
   <p:embeddedFontLst>
     <p:embeddedFont>
       <p:font typeface="Canva Sans Bold" charset="1" panose="020B0803030501040103"/>
-      <p:regular r:id="rId25"/>
+      <p:regular r:id="rId26"/>
     </p:embeddedFont>
     <p:embeddedFont>
       <p:font typeface="Canva Sans" charset="1" panose="020B0503030501040103"/>
-      <p:regular r:id="rId26"/>
+      <p:regular r:id="rId27"/>
     </p:embeddedFont>
   </p:embeddedFontLst>
   <p:defaultTextStyle>
@@ -3202,6 +3203,383 @@
         </p:nvSpPr>
         <p:spPr>
           <a:xfrm flipH="false" flipV="false" rot="0">
+            <a:off x="10238752" y="3259167"/>
+            <a:ext cx="7401946" cy="6450267"/>
+          </a:xfrm>
+          <a:custGeom>
+            <a:avLst/>
+            <a:gdLst/>
+            <a:ahLst/>
+            <a:cxnLst/>
+            <a:rect r="r" b="b" t="t" l="l"/>
+            <a:pathLst>
+              <a:path h="6450267" w="7401946">
+                <a:moveTo>
+                  <a:pt x="0" y="0"/>
+                </a:moveTo>
+                <a:lnTo>
+                  <a:pt x="7401945" y="0"/>
+                </a:lnTo>
+                <a:lnTo>
+                  <a:pt x="7401945" y="6450267"/>
+                </a:lnTo>
+                <a:lnTo>
+                  <a:pt x="0" y="6450267"/>
+                </a:lnTo>
+                <a:lnTo>
+                  <a:pt x="0" y="0"/>
+                </a:lnTo>
+                <a:close/>
+              </a:path>
+            </a:pathLst>
+          </a:custGeom>
+          <a:blipFill>
+            <a:blip r:embed="rId2"/>
+            <a:stretch>
+              <a:fillRect l="0" t="0" r="0" b="0"/>
+            </a:stretch>
+          </a:blipFill>
+        </p:spPr>
+      </p:sp>
+      <p:sp>
+        <p:nvSpPr>
+          <p:cNvPr name="TextBox 3" id="3"/>
+          <p:cNvSpPr txBox="true"/>
+          <p:nvPr/>
+        </p:nvSpPr>
+        <p:spPr>
+          <a:xfrm rot="0">
+            <a:off x="1238848" y="375983"/>
+            <a:ext cx="16020452" cy="2432050"/>
+          </a:xfrm>
+          <a:prstGeom prst="rect">
+            <a:avLst/>
+          </a:prstGeom>
+        </p:spPr>
+        <p:txBody>
+          <a:bodyPr anchor="t" rtlCol="false" tIns="0" lIns="0" bIns="0" rIns="0">
+            <a:spAutoFit/>
+          </a:bodyPr>
+          <a:lstStyle/>
+          <a:p>
+            <a:pPr algn="ctr">
+              <a:lnSpc>
+                <a:spcPts val="9799"/>
+              </a:lnSpc>
+            </a:pPr>
+            <a:r>
+              <a:rPr lang="en-US" sz="6999" b="true">
+                <a:solidFill>
+                  <a:srgbClr val="000000"/>
+                </a:solidFill>
+                <a:latin typeface="Canva Sans Bold"/>
+                <a:ea typeface="Canva Sans Bold"/>
+                <a:cs typeface="Canva Sans Bold"/>
+                <a:sym typeface="Canva Sans Bold"/>
+              </a:rPr>
+              <a:t>Dimension of weights and bias matrix in each layer</a:t>
+            </a:r>
+          </a:p>
+        </p:txBody>
+      </p:sp>
+      <p:sp>
+        <p:nvSpPr>
+          <p:cNvPr name="TextBox 4" id="4"/>
+          <p:cNvSpPr txBox="true"/>
+          <p:nvPr/>
+        </p:nvSpPr>
+        <p:spPr>
+          <a:xfrm rot="0">
+            <a:off x="1238848" y="3294378"/>
+            <a:ext cx="8187184" cy="1780540"/>
+          </a:xfrm>
+          <a:prstGeom prst="rect">
+            <a:avLst/>
+          </a:prstGeom>
+        </p:spPr>
+        <p:txBody>
+          <a:bodyPr anchor="t" rtlCol="false" tIns="0" lIns="0" bIns="0" rIns="0">
+            <a:spAutoFit/>
+          </a:bodyPr>
+          <a:lstStyle/>
+          <a:p>
+            <a:pPr algn="l">
+              <a:lnSpc>
+                <a:spcPts val="4759"/>
+              </a:lnSpc>
+            </a:pPr>
+            <a:r>
+              <a:rPr lang="en-US" sz="3399">
+                <a:solidFill>
+                  <a:srgbClr val="000000"/>
+                </a:solidFill>
+                <a:latin typeface="Canva Sans"/>
+                <a:ea typeface="Canva Sans"/>
+                <a:cs typeface="Canva Sans"/>
+                <a:sym typeface="Canva Sans"/>
+              </a:rPr>
+              <a:t>Weights and bias matrix could be found</a:t>
+            </a:r>
+          </a:p>
+          <a:p>
+            <a:pPr algn="l">
+              <a:lnSpc>
+                <a:spcPts val="4759"/>
+              </a:lnSpc>
+            </a:pPr>
+            <a:r>
+              <a:rPr lang="en-US" sz="3399">
+                <a:solidFill>
+                  <a:srgbClr val="000000"/>
+                </a:solidFill>
+                <a:latin typeface="Canva Sans"/>
+                <a:ea typeface="Canva Sans"/>
+                <a:cs typeface="Canva Sans"/>
+                <a:sym typeface="Canva Sans"/>
+              </a:rPr>
+              <a:t>by following the trends in the last two</a:t>
+            </a:r>
+          </a:p>
+          <a:p>
+            <a:pPr algn="l">
+              <a:lnSpc>
+                <a:spcPts val="4759"/>
+              </a:lnSpc>
+            </a:pPr>
+            <a:r>
+              <a:rPr lang="en-US" sz="3399">
+                <a:solidFill>
+                  <a:srgbClr val="000000"/>
+                </a:solidFill>
+                <a:latin typeface="Canva Sans"/>
+                <a:ea typeface="Canva Sans"/>
+                <a:cs typeface="Canva Sans"/>
+                <a:sym typeface="Canva Sans"/>
+              </a:rPr>
+              <a:t>slides.</a:t>
+            </a:r>
+          </a:p>
+        </p:txBody>
+      </p:sp>
+      <p:sp>
+        <p:nvSpPr>
+          <p:cNvPr name="TextBox 5" id="5"/>
+          <p:cNvSpPr txBox="true"/>
+          <p:nvPr/>
+        </p:nvSpPr>
+        <p:spPr>
+          <a:xfrm rot="0">
+            <a:off x="1238848" y="5560693"/>
+            <a:ext cx="7875389" cy="1780540"/>
+          </a:xfrm>
+          <a:prstGeom prst="rect">
+            <a:avLst/>
+          </a:prstGeom>
+        </p:spPr>
+        <p:txBody>
+          <a:bodyPr anchor="t" rtlCol="false" tIns="0" lIns="0" bIns="0" rIns="0">
+            <a:spAutoFit/>
+          </a:bodyPr>
+          <a:lstStyle/>
+          <a:p>
+            <a:pPr algn="l">
+              <a:lnSpc>
+                <a:spcPts val="4759"/>
+              </a:lnSpc>
+            </a:pPr>
+            <a:r>
+              <a:rPr lang="en-US" sz="3399">
+                <a:solidFill>
+                  <a:srgbClr val="000000"/>
+                </a:solidFill>
+                <a:latin typeface="Canva Sans"/>
+                <a:ea typeface="Canva Sans"/>
+                <a:cs typeface="Canva Sans"/>
+                <a:sym typeface="Canva Sans"/>
+              </a:rPr>
+              <a:t>One observable point is that for every</a:t>
+            </a:r>
+          </a:p>
+          <a:p>
+            <a:pPr algn="l" marL="734059" indent="-367030" lvl="1">
+              <a:lnSpc>
+                <a:spcPts val="4759"/>
+              </a:lnSpc>
+              <a:buAutoNum type="arabicPeriod" startAt="1"/>
+            </a:pPr>
+            <a:r>
+              <a:rPr lang="en-US" sz="3399">
+                <a:solidFill>
+                  <a:srgbClr val="000000"/>
+                </a:solidFill>
+                <a:latin typeface="Canva Sans"/>
+                <a:ea typeface="Canva Sans"/>
+                <a:cs typeface="Canva Sans"/>
+                <a:sym typeface="Canva Sans"/>
+              </a:rPr>
+              <a:t>Weight matrix ⟶ (n_in, n_out)</a:t>
+            </a:r>
+          </a:p>
+          <a:p>
+            <a:pPr algn="l" marL="734059" indent="-367030" lvl="1">
+              <a:lnSpc>
+                <a:spcPts val="4759"/>
+              </a:lnSpc>
+              <a:buAutoNum type="arabicPeriod" startAt="1"/>
+            </a:pPr>
+            <a:r>
+              <a:rPr lang="en-US" sz="3399">
+                <a:solidFill>
+                  <a:srgbClr val="000000"/>
+                </a:solidFill>
+                <a:latin typeface="Canva Sans"/>
+                <a:ea typeface="Canva Sans"/>
+                <a:cs typeface="Canva Sans"/>
+                <a:sym typeface="Canva Sans"/>
+              </a:rPr>
+              <a:t>Bias matrix ⟶ (1, n_out)</a:t>
+            </a:r>
+          </a:p>
+        </p:txBody>
+      </p:sp>
+      <p:sp>
+        <p:nvSpPr>
+          <p:cNvPr name="TextBox 6" id="6"/>
+          <p:cNvSpPr txBox="true"/>
+          <p:nvPr/>
+        </p:nvSpPr>
+        <p:spPr>
+          <a:xfrm rot="0">
+            <a:off x="1238848" y="7607695"/>
+            <a:ext cx="7473925" cy="2184399"/>
+          </a:xfrm>
+          <a:prstGeom prst="rect">
+            <a:avLst/>
+          </a:prstGeom>
+        </p:spPr>
+        <p:txBody>
+          <a:bodyPr anchor="t" rtlCol="false" tIns="0" lIns="0" bIns="0" rIns="0">
+            <a:spAutoFit/>
+          </a:bodyPr>
+          <a:lstStyle/>
+          <a:p>
+            <a:pPr algn="l">
+              <a:lnSpc>
+                <a:spcPts val="3500"/>
+              </a:lnSpc>
+            </a:pPr>
+            <a:r>
+              <a:rPr lang="en-US" sz="2500">
+                <a:solidFill>
+                  <a:srgbClr val="000000"/>
+                </a:solidFill>
+                <a:latin typeface="Canva Sans"/>
+                <a:ea typeface="Canva Sans"/>
+                <a:cs typeface="Canva Sans"/>
+                <a:sym typeface="Canva Sans"/>
+              </a:rPr>
+              <a:t>where n_in = number of inputs for layer (or)</a:t>
+            </a:r>
+          </a:p>
+          <a:p>
+            <a:pPr algn="l">
+              <a:lnSpc>
+                <a:spcPts val="3500"/>
+              </a:lnSpc>
+            </a:pPr>
+            <a:r>
+              <a:rPr lang="en-US" sz="2500">
+                <a:solidFill>
+                  <a:srgbClr val="000000"/>
+                </a:solidFill>
+                <a:latin typeface="Canva Sans"/>
+                <a:ea typeface="Canva Sans"/>
+                <a:cs typeface="Canva Sans"/>
+                <a:sym typeface="Canva Sans"/>
+              </a:rPr>
+              <a:t>                         number of neurons in previous layer</a:t>
+            </a:r>
+          </a:p>
+          <a:p>
+            <a:pPr algn="l">
+              <a:lnSpc>
+                <a:spcPts val="3500"/>
+              </a:lnSpc>
+            </a:pPr>
+          </a:p>
+          <a:p>
+            <a:pPr algn="l">
+              <a:lnSpc>
+                <a:spcPts val="3500"/>
+              </a:lnSpc>
+            </a:pPr>
+            <a:r>
+              <a:rPr lang="en-US" sz="2500">
+                <a:solidFill>
+                  <a:srgbClr val="000000"/>
+                </a:solidFill>
+                <a:latin typeface="Canva Sans"/>
+                <a:ea typeface="Canva Sans"/>
+                <a:cs typeface="Canva Sans"/>
+                <a:sym typeface="Canva Sans"/>
+              </a:rPr>
+              <a:t>n_out = number of outputs by layer (or)</a:t>
+            </a:r>
+          </a:p>
+          <a:p>
+            <a:pPr algn="l">
+              <a:lnSpc>
+                <a:spcPts val="3500"/>
+              </a:lnSpc>
+            </a:pPr>
+            <a:r>
+              <a:rPr lang="en-US" sz="2500">
+                <a:solidFill>
+                  <a:srgbClr val="000000"/>
+                </a:solidFill>
+                <a:latin typeface="Canva Sans"/>
+                <a:ea typeface="Canva Sans"/>
+                <a:cs typeface="Canva Sans"/>
+                <a:sym typeface="Canva Sans"/>
+              </a:rPr>
+              <a:t>               number of neurons in current layer</a:t>
+            </a:r>
+          </a:p>
+        </p:txBody>
+      </p:sp>
+    </p:spTree>
+  </p:cSld>
+  <p:clrMapOvr>
+    <a:masterClrMapping/>
+  </p:clrMapOvr>
+</p:sld>
+</file>
+
+<file path=ppt/slides/slide11.xml><?xml version="1.0" encoding="utf-8"?>
+<p:sld xmlns:p="http://schemas.openxmlformats.org/presentationml/2006/main" xmlns:a="http://schemas.openxmlformats.org/drawingml/2006/main" xmlns:r="http://schemas.openxmlformats.org/officeDocument/2006/relationships">
+  <p:cSld>
+    <p:spTree>
+      <p:nvGrpSpPr>
+        <p:cNvPr id="1" name=""/>
+        <p:cNvGrpSpPr/>
+        <p:nvPr/>
+      </p:nvGrpSpPr>
+      <p:grpSpPr>
+        <a:xfrm>
+          <a:off x="0" y="0"/>
+          <a:ext cx="0" cy="0"/>
+          <a:chOff x="0" y="0"/>
+          <a:chExt cx="0" cy="0"/>
+        </a:xfrm>
+      </p:grpSpPr>
+      <p:sp>
+        <p:nvSpPr>
+          <p:cNvPr name="Freeform 2" id="2"/>
+          <p:cNvSpPr/>
+          <p:nvPr/>
+        </p:nvSpPr>
+        <p:spPr>
+          <a:xfrm flipH="false" flipV="false" rot="0">
             <a:off x="10959352" y="163648"/>
             <a:ext cx="7093305" cy="5116534"/>
           </a:xfrm>
@@ -3568,7 +3946,7 @@
 </p:sld>
 </file>
 
-<file path=ppt/slides/slide11.xml><?xml version="1.0" encoding="utf-8"?>
+<file path=ppt/slides/slide12.xml><?xml version="1.0" encoding="utf-8"?>
 <p:sld xmlns:p="http://schemas.openxmlformats.org/presentationml/2006/main" xmlns:a="http://schemas.openxmlformats.org/drawingml/2006/main" xmlns:r="http://schemas.openxmlformats.org/officeDocument/2006/relationships">
   <p:cSld>
     <p:spTree>
@@ -3940,7 +4318,7 @@
 </p:sld>
 </file>
 
-<file path=ppt/slides/slide12.xml><?xml version="1.0" encoding="utf-8"?>
+<file path=ppt/slides/slide13.xml><?xml version="1.0" encoding="utf-8"?>
 <p:sld xmlns:p="http://schemas.openxmlformats.org/presentationml/2006/main" xmlns:a="http://schemas.openxmlformats.org/drawingml/2006/main" xmlns:r="http://schemas.openxmlformats.org/officeDocument/2006/relationships">
   <p:cSld>
     <p:spTree>
@@ -4301,7 +4679,7 @@
 </p:sld>
 </file>
 
-<file path=ppt/slides/slide13.xml><?xml version="1.0" encoding="utf-8"?>
+<file path=ppt/slides/slide14.xml><?xml version="1.0" encoding="utf-8"?>
 <p:sld xmlns:p="http://schemas.openxmlformats.org/presentationml/2006/main" xmlns:a="http://schemas.openxmlformats.org/drawingml/2006/main" xmlns:r="http://schemas.openxmlformats.org/officeDocument/2006/relationships">
   <p:cSld>
     <p:spTree>
@@ -4750,7 +5128,7 @@
 </p:sld>
 </file>
 
-<file path=ppt/slides/slide14.xml><?xml version="1.0" encoding="utf-8"?>
+<file path=ppt/slides/slide15.xml><?xml version="1.0" encoding="utf-8"?>
 <p:sld xmlns:p="http://schemas.openxmlformats.org/presentationml/2006/main" xmlns:a="http://schemas.openxmlformats.org/drawingml/2006/main" xmlns:r="http://schemas.openxmlformats.org/officeDocument/2006/relationships">
   <p:cSld>
     <p:spTree>
@@ -5136,7 +5514,7 @@
 </p:sld>
 </file>
 
-<file path=ppt/slides/slide15.xml><?xml version="1.0" encoding="utf-8"?>
+<file path=ppt/slides/slide16.xml><?xml version="1.0" encoding="utf-8"?>
 <p:sld xmlns:p="http://schemas.openxmlformats.org/presentationml/2006/main" xmlns:a="http://schemas.openxmlformats.org/drawingml/2006/main" xmlns:r="http://schemas.openxmlformats.org/officeDocument/2006/relationships">
   <p:cSld>
     <p:spTree>
@@ -5392,7 +5770,7 @@
 </p:sld>
 </file>
 
-<file path=ppt/slides/slide16.xml><?xml version="1.0" encoding="utf-8"?>
+<file path=ppt/slides/slide17.xml><?xml version="1.0" encoding="utf-8"?>
 <p:sld xmlns:p="http://schemas.openxmlformats.org/presentationml/2006/main" xmlns:a="http://schemas.openxmlformats.org/drawingml/2006/main" xmlns:r="http://schemas.openxmlformats.org/officeDocument/2006/relationships">
   <p:cSld>
     <p:spTree>
@@ -5648,7 +6026,7 @@
 </p:sld>
 </file>
 
-<file path=ppt/slides/slide17.xml><?xml version="1.0" encoding="utf-8"?>
+<file path=ppt/slides/slide18.xml><?xml version="1.0" encoding="utf-8"?>
 <p:sld xmlns:p="http://schemas.openxmlformats.org/presentationml/2006/main" xmlns:a="http://schemas.openxmlformats.org/drawingml/2006/main" xmlns:r="http://schemas.openxmlformats.org/officeDocument/2006/relationships">
   <p:cSld>
     <p:spTree>
@@ -5858,680 +6236,6 @@
 </p:sld>
 </file>
 
-<file path=ppt/slides/slide18.xml><?xml version="1.0" encoding="utf-8"?>
-<p:sld xmlns:p="http://schemas.openxmlformats.org/presentationml/2006/main" xmlns:a="http://schemas.openxmlformats.org/drawingml/2006/main">
-  <p:cSld>
-    <p:spTree>
-      <p:nvGrpSpPr>
-        <p:cNvPr id="1" name=""/>
-        <p:cNvGrpSpPr/>
-        <p:nvPr/>
-      </p:nvGrpSpPr>
-      <p:grpSpPr>
-        <a:xfrm>
-          <a:off x="0" y="0"/>
-          <a:ext cx="0" cy="0"/>
-          <a:chOff x="0" y="0"/>
-          <a:chExt cx="0" cy="0"/>
-        </a:xfrm>
-      </p:grpSpPr>
-      <p:sp>
-        <p:nvSpPr>
-          <p:cNvPr name="TextBox 2" id="2"/>
-          <p:cNvSpPr txBox="true"/>
-          <p:nvPr/>
-        </p:nvSpPr>
-        <p:spPr>
-          <a:xfrm rot="0">
-            <a:off x="665945" y="1047869"/>
-            <a:ext cx="7562701" cy="887095"/>
-          </a:xfrm>
-          <a:prstGeom prst="rect">
-            <a:avLst/>
-          </a:prstGeom>
-        </p:spPr>
-        <p:txBody>
-          <a:bodyPr anchor="t" rtlCol="false" tIns="0" lIns="0" bIns="0" rIns="0">
-            <a:spAutoFit/>
-          </a:bodyPr>
-          <a:lstStyle/>
-          <a:p>
-            <a:pPr algn="ctr">
-              <a:lnSpc>
-                <a:spcPts val="7279"/>
-              </a:lnSpc>
-            </a:pPr>
-            <a:r>
-              <a:rPr lang="en-US" sz="5199" b="true">
-                <a:solidFill>
-                  <a:srgbClr val="000000"/>
-                </a:solidFill>
-                <a:latin typeface="Canva Sans Bold"/>
-                <a:ea typeface="Canva Sans Bold"/>
-                <a:cs typeface="Canva Sans Bold"/>
-                <a:sym typeface="Canva Sans Bold"/>
-              </a:rPr>
-              <a:t>Scratch Implementaion</a:t>
-            </a:r>
-          </a:p>
-        </p:txBody>
-      </p:sp>
-      <p:sp>
-        <p:nvSpPr>
-          <p:cNvPr name="TextBox 3" id="3"/>
-          <p:cNvSpPr txBox="true"/>
-          <p:nvPr/>
-        </p:nvSpPr>
-        <p:spPr>
-          <a:xfrm rot="0">
-            <a:off x="8953301" y="1047869"/>
-            <a:ext cx="8953723" cy="887095"/>
-          </a:xfrm>
-          <a:prstGeom prst="rect">
-            <a:avLst/>
-          </a:prstGeom>
-        </p:spPr>
-        <p:txBody>
-          <a:bodyPr anchor="t" rtlCol="false" tIns="0" lIns="0" bIns="0" rIns="0">
-            <a:spAutoFit/>
-          </a:bodyPr>
-          <a:lstStyle/>
-          <a:p>
-            <a:pPr algn="ctr">
-              <a:lnSpc>
-                <a:spcPts val="7279"/>
-              </a:lnSpc>
-            </a:pPr>
-            <a:r>
-              <a:rPr lang="en-US" sz="5199" b="true">
-                <a:solidFill>
-                  <a:srgbClr val="000000"/>
-                </a:solidFill>
-                <a:latin typeface="Canva Sans Bold"/>
-                <a:ea typeface="Canva Sans Bold"/>
-                <a:cs typeface="Canva Sans Bold"/>
-                <a:sym typeface="Canva Sans Bold"/>
-              </a:rPr>
-              <a:t>Framework Implementation</a:t>
-            </a:r>
-          </a:p>
-        </p:txBody>
-      </p:sp>
-      <p:sp>
-        <p:nvSpPr>
-          <p:cNvPr name="AutoShape 4" id="4"/>
-          <p:cNvSpPr/>
-          <p:nvPr/>
-        </p:nvSpPr>
-        <p:spPr>
-          <a:xfrm>
-            <a:off x="8590974" y="1143119"/>
-            <a:ext cx="0" cy="8115181"/>
-          </a:xfrm>
-          <a:prstGeom prst="line">
-            <a:avLst/>
-          </a:prstGeom>
-          <a:ln cap="flat" w="38100">
-            <a:solidFill>
-              <a:srgbClr val="000000"/>
-            </a:solidFill>
-            <a:prstDash val="solid"/>
-            <a:headEnd type="none" len="sm" w="sm"/>
-            <a:tailEnd type="none" len="sm" w="sm"/>
-          </a:ln>
-        </p:spPr>
-      </p:sp>
-      <p:sp>
-        <p:nvSpPr>
-          <p:cNvPr name="TextBox 5" id="5"/>
-          <p:cNvSpPr txBox="true"/>
-          <p:nvPr/>
-        </p:nvSpPr>
-        <p:spPr>
-          <a:xfrm rot="0">
-            <a:off x="831219" y="2340885"/>
-            <a:ext cx="5242620" cy="1180465"/>
-          </a:xfrm>
-          <a:prstGeom prst="rect">
-            <a:avLst/>
-          </a:prstGeom>
-        </p:spPr>
-        <p:txBody>
-          <a:bodyPr anchor="t" rtlCol="false" tIns="0" lIns="0" bIns="0" rIns="0">
-            <a:spAutoFit/>
-          </a:bodyPr>
-          <a:lstStyle/>
-          <a:p>
-            <a:pPr algn="ctr">
-              <a:lnSpc>
-                <a:spcPts val="4759"/>
-              </a:lnSpc>
-            </a:pPr>
-            <a:r>
-              <a:rPr lang="en-US" sz="3399">
-                <a:solidFill>
-                  <a:srgbClr val="000000"/>
-                </a:solidFill>
-                <a:latin typeface="Canva Sans"/>
-                <a:ea typeface="Canva Sans"/>
-                <a:cs typeface="Canva Sans"/>
-                <a:sym typeface="Canva Sans"/>
-              </a:rPr>
-              <a:t>Max accuracy: 98.0556 %</a:t>
-            </a:r>
-          </a:p>
-          <a:p>
-            <a:pPr algn="ctr">
-              <a:lnSpc>
-                <a:spcPts val="4759"/>
-              </a:lnSpc>
-            </a:pPr>
-            <a:r>
-              <a:rPr lang="en-US" sz="3399">
-                <a:solidFill>
-                  <a:srgbClr val="000000"/>
-                </a:solidFill>
-                <a:latin typeface="Canva Sans"/>
-                <a:ea typeface="Canva Sans"/>
-                <a:cs typeface="Canva Sans"/>
-                <a:sym typeface="Canva Sans"/>
-              </a:rPr>
-              <a:t>Most of the time: ~97.5%</a:t>
-            </a:r>
-          </a:p>
-        </p:txBody>
-      </p:sp>
-      <p:sp>
-        <p:nvSpPr>
-          <p:cNvPr name="TextBox 6" id="6"/>
-          <p:cNvSpPr txBox="true"/>
-          <p:nvPr/>
-        </p:nvSpPr>
-        <p:spPr>
-          <a:xfrm rot="0">
-            <a:off x="9801330" y="2384065"/>
-            <a:ext cx="5245373" cy="1180465"/>
-          </a:xfrm>
-          <a:prstGeom prst="rect">
-            <a:avLst/>
-          </a:prstGeom>
-        </p:spPr>
-        <p:txBody>
-          <a:bodyPr anchor="t" rtlCol="false" tIns="0" lIns="0" bIns="0" rIns="0">
-            <a:spAutoFit/>
-          </a:bodyPr>
-          <a:lstStyle/>
-          <a:p>
-            <a:pPr algn="ctr">
-              <a:lnSpc>
-                <a:spcPts val="4759"/>
-              </a:lnSpc>
-            </a:pPr>
-            <a:r>
-              <a:rPr lang="en-US" sz="3399">
-                <a:solidFill>
-                  <a:srgbClr val="000000"/>
-                </a:solidFill>
-                <a:latin typeface="Canva Sans"/>
-                <a:ea typeface="Canva Sans"/>
-                <a:cs typeface="Canva Sans"/>
-                <a:sym typeface="Canva Sans"/>
-              </a:rPr>
-              <a:t>Max accuracy: 98.33%</a:t>
-            </a:r>
-          </a:p>
-          <a:p>
-            <a:pPr algn="ctr">
-              <a:lnSpc>
-                <a:spcPts val="4759"/>
-              </a:lnSpc>
-            </a:pPr>
-            <a:r>
-              <a:rPr lang="en-US" sz="3399">
-                <a:solidFill>
-                  <a:srgbClr val="000000"/>
-                </a:solidFill>
-                <a:latin typeface="Canva Sans"/>
-                <a:ea typeface="Canva Sans"/>
-                <a:cs typeface="Canva Sans"/>
-                <a:sym typeface="Canva Sans"/>
-              </a:rPr>
-              <a:t>Most of the time: ~97.78%</a:t>
-            </a:r>
-          </a:p>
-        </p:txBody>
-      </p:sp>
-      <p:sp>
-        <p:nvSpPr>
-          <p:cNvPr name="TextBox 7" id="7"/>
-          <p:cNvSpPr txBox="true"/>
-          <p:nvPr/>
-        </p:nvSpPr>
-        <p:spPr>
-          <a:xfrm rot="0">
-            <a:off x="922384" y="3933804"/>
-            <a:ext cx="3833440" cy="580390"/>
-          </a:xfrm>
-          <a:prstGeom prst="rect">
-            <a:avLst/>
-          </a:prstGeom>
-        </p:spPr>
-        <p:txBody>
-          <a:bodyPr anchor="t" rtlCol="false" tIns="0" lIns="0" bIns="0" rIns="0">
-            <a:spAutoFit/>
-          </a:bodyPr>
-          <a:lstStyle/>
-          <a:p>
-            <a:pPr algn="l">
-              <a:lnSpc>
-                <a:spcPts val="4759"/>
-              </a:lnSpc>
-            </a:pPr>
-            <a:r>
-              <a:rPr lang="en-US" sz="3399">
-                <a:solidFill>
-                  <a:srgbClr val="000000"/>
-                </a:solidFill>
-                <a:latin typeface="Canva Sans"/>
-                <a:ea typeface="Canva Sans"/>
-                <a:cs typeface="Canva Sans"/>
-                <a:sym typeface="Canva Sans"/>
-              </a:rPr>
-              <a:t>More lines of code</a:t>
-            </a:r>
-          </a:p>
-        </p:txBody>
-      </p:sp>
-      <p:sp>
-        <p:nvSpPr>
-          <p:cNvPr name="TextBox 8" id="8"/>
-          <p:cNvSpPr txBox="true"/>
-          <p:nvPr/>
-        </p:nvSpPr>
-        <p:spPr>
-          <a:xfrm rot="0">
-            <a:off x="9801330" y="3933804"/>
-            <a:ext cx="5848127" cy="580390"/>
-          </a:xfrm>
-          <a:prstGeom prst="rect">
-            <a:avLst/>
-          </a:prstGeom>
-        </p:spPr>
-        <p:txBody>
-          <a:bodyPr anchor="t" rtlCol="false" tIns="0" lIns="0" bIns="0" rIns="0">
-            <a:spAutoFit/>
-          </a:bodyPr>
-          <a:lstStyle/>
-          <a:p>
-            <a:pPr algn="l">
-              <a:lnSpc>
-                <a:spcPts val="4759"/>
-              </a:lnSpc>
-            </a:pPr>
-            <a:r>
-              <a:rPr lang="en-US" sz="3399">
-                <a:solidFill>
-                  <a:srgbClr val="000000"/>
-                </a:solidFill>
-                <a:latin typeface="Canva Sans"/>
-                <a:ea typeface="Canva Sans"/>
-                <a:cs typeface="Canva Sans"/>
-                <a:sym typeface="Canva Sans"/>
-              </a:rPr>
-              <a:t>2 to 3 times less line of code</a:t>
-            </a:r>
-          </a:p>
-        </p:txBody>
-      </p:sp>
-      <p:sp>
-        <p:nvSpPr>
-          <p:cNvPr name="TextBox 9" id="9"/>
-          <p:cNvSpPr txBox="true"/>
-          <p:nvPr/>
-        </p:nvSpPr>
-        <p:spPr>
-          <a:xfrm rot="0">
-            <a:off x="831219" y="4923769"/>
-            <a:ext cx="5619676" cy="1180465"/>
-          </a:xfrm>
-          <a:prstGeom prst="rect">
-            <a:avLst/>
-          </a:prstGeom>
-        </p:spPr>
-        <p:txBody>
-          <a:bodyPr anchor="t" rtlCol="false" tIns="0" lIns="0" bIns="0" rIns="0">
-            <a:spAutoFit/>
-          </a:bodyPr>
-          <a:lstStyle/>
-          <a:p>
-            <a:pPr algn="ctr">
-              <a:lnSpc>
-                <a:spcPts val="4759"/>
-              </a:lnSpc>
-            </a:pPr>
-            <a:r>
-              <a:rPr lang="en-US" sz="3399">
-                <a:solidFill>
-                  <a:srgbClr val="000000"/>
-                </a:solidFill>
-                <a:latin typeface="Canva Sans"/>
-                <a:ea typeface="Canva Sans"/>
-                <a:cs typeface="Canva Sans"/>
-                <a:sym typeface="Canva Sans"/>
-              </a:rPr>
-              <a:t>No optimization untill  self-</a:t>
-            </a:r>
-          </a:p>
-          <a:p>
-            <a:pPr algn="ctr">
-              <a:lnSpc>
-                <a:spcPts val="4759"/>
-              </a:lnSpc>
-            </a:pPr>
-            <a:r>
-              <a:rPr lang="en-US" sz="3399">
-                <a:solidFill>
-                  <a:srgbClr val="000000"/>
-                </a:solidFill>
-                <a:latin typeface="Canva Sans"/>
-                <a:ea typeface="Canva Sans"/>
-                <a:cs typeface="Canva Sans"/>
-                <a:sym typeface="Canva Sans"/>
-              </a:rPr>
-              <a:t>implemented from scratch</a:t>
-            </a:r>
-          </a:p>
-        </p:txBody>
-      </p:sp>
-      <p:sp>
-        <p:nvSpPr>
-          <p:cNvPr name="TextBox 10" id="10"/>
-          <p:cNvSpPr txBox="true"/>
-          <p:nvPr/>
-        </p:nvSpPr>
-        <p:spPr>
-          <a:xfrm rot="0">
-            <a:off x="9801330" y="4880590"/>
-            <a:ext cx="8486670" cy="1780540"/>
-          </a:xfrm>
-          <a:prstGeom prst="rect">
-            <a:avLst/>
-          </a:prstGeom>
-        </p:spPr>
-        <p:txBody>
-          <a:bodyPr anchor="t" rtlCol="false" tIns="0" lIns="0" bIns="0" rIns="0">
-            <a:spAutoFit/>
-          </a:bodyPr>
-          <a:lstStyle/>
-          <a:p>
-            <a:pPr algn="l">
-              <a:lnSpc>
-                <a:spcPts val="4759"/>
-              </a:lnSpc>
-            </a:pPr>
-            <a:r>
-              <a:rPr lang="en-US" sz="3399">
-                <a:solidFill>
-                  <a:srgbClr val="000000"/>
-                </a:solidFill>
-                <a:latin typeface="Canva Sans"/>
-                <a:ea typeface="Canva Sans"/>
-                <a:cs typeface="Canva Sans"/>
-                <a:sym typeface="Canva Sans"/>
-              </a:rPr>
-              <a:t>Automatic optimization in many ways,</a:t>
-            </a:r>
-          </a:p>
-          <a:p>
-            <a:pPr algn="l">
-              <a:lnSpc>
-                <a:spcPts val="4759"/>
-              </a:lnSpc>
-            </a:pPr>
-            <a:r>
-              <a:rPr lang="en-US" sz="3399">
-                <a:solidFill>
-                  <a:srgbClr val="000000"/>
-                </a:solidFill>
-                <a:latin typeface="Canva Sans"/>
-                <a:ea typeface="Canva Sans"/>
-                <a:cs typeface="Canva Sans"/>
-                <a:sym typeface="Canva Sans"/>
-              </a:rPr>
-              <a:t>in training, in data handling, in calculation, etc.</a:t>
-            </a:r>
-          </a:p>
-        </p:txBody>
-      </p:sp>
-      <p:sp>
-        <p:nvSpPr>
-          <p:cNvPr name="TextBox 11" id="11"/>
-          <p:cNvSpPr txBox="true"/>
-          <p:nvPr/>
-        </p:nvSpPr>
-        <p:spPr>
-          <a:xfrm rot="0">
-            <a:off x="831219" y="6594455"/>
-            <a:ext cx="4733851" cy="580390"/>
-          </a:xfrm>
-          <a:prstGeom prst="rect">
-            <a:avLst/>
-          </a:prstGeom>
-        </p:spPr>
-        <p:txBody>
-          <a:bodyPr anchor="t" rtlCol="false" tIns="0" lIns="0" bIns="0" rIns="0">
-            <a:spAutoFit/>
-          </a:bodyPr>
-          <a:lstStyle/>
-          <a:p>
-            <a:pPr algn="l">
-              <a:lnSpc>
-                <a:spcPts val="4759"/>
-              </a:lnSpc>
-            </a:pPr>
-            <a:r>
-              <a:rPr lang="en-US" sz="3399">
-                <a:solidFill>
-                  <a:srgbClr val="000000"/>
-                </a:solidFill>
-                <a:latin typeface="Canva Sans"/>
-                <a:ea typeface="Canva Sans"/>
-                <a:cs typeface="Canva Sans"/>
-                <a:sym typeface="Canva Sans"/>
-              </a:rPr>
-              <a:t>Less memory efficient.</a:t>
-            </a:r>
-          </a:p>
-        </p:txBody>
-      </p:sp>
-      <p:sp>
-        <p:nvSpPr>
-          <p:cNvPr name="TextBox 12" id="12"/>
-          <p:cNvSpPr txBox="true"/>
-          <p:nvPr/>
-        </p:nvSpPr>
-        <p:spPr>
-          <a:xfrm rot="0">
-            <a:off x="9801330" y="6877685"/>
-            <a:ext cx="8105694" cy="1180465"/>
-          </a:xfrm>
-          <a:prstGeom prst="rect">
-            <a:avLst/>
-          </a:prstGeom>
-        </p:spPr>
-        <p:txBody>
-          <a:bodyPr anchor="t" rtlCol="false" tIns="0" lIns="0" bIns="0" rIns="0">
-            <a:spAutoFit/>
-          </a:bodyPr>
-          <a:lstStyle/>
-          <a:p>
-            <a:pPr algn="l">
-              <a:lnSpc>
-                <a:spcPts val="4759"/>
-              </a:lnSpc>
-            </a:pPr>
-            <a:r>
-              <a:rPr lang="en-US" sz="3399">
-                <a:solidFill>
-                  <a:srgbClr val="000000"/>
-                </a:solidFill>
-                <a:latin typeface="Canva Sans"/>
-                <a:ea typeface="Canva Sans"/>
-                <a:cs typeface="Canva Sans"/>
-                <a:sym typeface="Canva Sans"/>
-              </a:rPr>
-              <a:t>More memory efficient because of optimized code and implementation</a:t>
-            </a:r>
-          </a:p>
-        </p:txBody>
-      </p:sp>
-      <p:sp>
-        <p:nvSpPr>
-          <p:cNvPr name="TextBox 13" id="13"/>
-          <p:cNvSpPr txBox="true"/>
-          <p:nvPr/>
-        </p:nvSpPr>
-        <p:spPr>
-          <a:xfrm rot="0">
-            <a:off x="665945" y="7434580"/>
-            <a:ext cx="7786836" cy="1780540"/>
-          </a:xfrm>
-          <a:prstGeom prst="rect">
-            <a:avLst/>
-          </a:prstGeom>
-        </p:spPr>
-        <p:txBody>
-          <a:bodyPr anchor="t" rtlCol="false" tIns="0" lIns="0" bIns="0" rIns="0">
-            <a:spAutoFit/>
-          </a:bodyPr>
-          <a:lstStyle/>
-          <a:p>
-            <a:pPr algn="l">
-              <a:lnSpc>
-                <a:spcPts val="4759"/>
-              </a:lnSpc>
-            </a:pPr>
-            <a:r>
-              <a:rPr lang="en-US" sz="3399">
-                <a:solidFill>
-                  <a:srgbClr val="000000"/>
-                </a:solidFill>
-                <a:latin typeface="Canva Sans"/>
-                <a:ea typeface="Canva Sans"/>
-                <a:cs typeface="Canva Sans"/>
-                <a:sym typeface="Canva Sans"/>
-              </a:rPr>
-              <a:t>This implementation is made for only</a:t>
-            </a:r>
-          </a:p>
-          <a:p>
-            <a:pPr algn="l">
-              <a:lnSpc>
-                <a:spcPts val="4759"/>
-              </a:lnSpc>
-            </a:pPr>
-            <a:r>
-              <a:rPr lang="en-US" sz="3399">
-                <a:solidFill>
-                  <a:srgbClr val="000000"/>
-                </a:solidFill>
-                <a:latin typeface="Canva Sans"/>
-                <a:ea typeface="Canva Sans"/>
-                <a:cs typeface="Canva Sans"/>
-                <a:sym typeface="Canva Sans"/>
-              </a:rPr>
-              <a:t>this type of model, with crossentropy</a:t>
-            </a:r>
-          </a:p>
-          <a:p>
-            <a:pPr algn="l">
-              <a:lnSpc>
-                <a:spcPts val="4759"/>
-              </a:lnSpc>
-            </a:pPr>
-            <a:r>
-              <a:rPr lang="en-US" sz="3399">
-                <a:solidFill>
-                  <a:srgbClr val="000000"/>
-                </a:solidFill>
-                <a:latin typeface="Canva Sans"/>
-                <a:ea typeface="Canva Sans"/>
-                <a:cs typeface="Canva Sans"/>
-                <a:sym typeface="Canva Sans"/>
-              </a:rPr>
-              <a:t>loss, relu and softmax activation.</a:t>
-            </a:r>
-          </a:p>
-        </p:txBody>
-      </p:sp>
-      <p:sp>
-        <p:nvSpPr>
-          <p:cNvPr name="TextBox 14" id="14"/>
-          <p:cNvSpPr txBox="true"/>
-          <p:nvPr/>
-        </p:nvSpPr>
-        <p:spPr>
-          <a:xfrm rot="0">
-            <a:off x="9801330" y="8277225"/>
-            <a:ext cx="7578179" cy="1180465"/>
-          </a:xfrm>
-          <a:prstGeom prst="rect">
-            <a:avLst/>
-          </a:prstGeom>
-        </p:spPr>
-        <p:txBody>
-          <a:bodyPr anchor="t" rtlCol="false" tIns="0" lIns="0" bIns="0" rIns="0">
-            <a:spAutoFit/>
-          </a:bodyPr>
-          <a:lstStyle/>
-          <a:p>
-            <a:pPr algn="l">
-              <a:lnSpc>
-                <a:spcPts val="4759"/>
-              </a:lnSpc>
-            </a:pPr>
-            <a:r>
-              <a:rPr lang="en-US" sz="3399">
-                <a:solidFill>
-                  <a:srgbClr val="000000"/>
-                </a:solidFill>
-                <a:latin typeface="Canva Sans"/>
-                <a:ea typeface="Canva Sans"/>
-                <a:cs typeface="Canva Sans"/>
-                <a:sym typeface="Canva Sans"/>
-              </a:rPr>
-              <a:t>Works for all types of activation and </a:t>
-            </a:r>
-          </a:p>
-          <a:p>
-            <a:pPr algn="l">
-              <a:lnSpc>
-                <a:spcPts val="4759"/>
-              </a:lnSpc>
-            </a:pPr>
-            <a:r>
-              <a:rPr lang="en-US" sz="3399">
-                <a:solidFill>
-                  <a:srgbClr val="000000"/>
-                </a:solidFill>
-                <a:latin typeface="Canva Sans"/>
-                <a:ea typeface="Canva Sans"/>
-                <a:cs typeface="Canva Sans"/>
-                <a:sym typeface="Canva Sans"/>
-              </a:rPr>
-              <a:t>loss function with better options.</a:t>
-            </a:r>
-          </a:p>
-        </p:txBody>
-      </p:sp>
-    </p:spTree>
-  </p:cSld>
-  <p:clrMapOvr>
-    <a:masterClrMapping/>
-  </p:clrMapOvr>
-</p:sld>
-</file>
-
 <file path=ppt/slides/slide19.xml><?xml version="1.0" encoding="utf-8"?>
 <p:sld xmlns:p="http://schemas.openxmlformats.org/presentationml/2006/main" xmlns:a="http://schemas.openxmlformats.org/drawingml/2006/main">
   <p:cSld>
@@ -6557,8 +6261,8 @@
         </p:nvSpPr>
         <p:spPr>
           <a:xfrm rot="0">
-            <a:off x="0" y="4819967"/>
-            <a:ext cx="18288000" cy="2980690"/>
+            <a:off x="665945" y="1047869"/>
+            <a:ext cx="7562701" cy="887095"/>
           </a:xfrm>
           <a:prstGeom prst="rect">
             <a:avLst/>
@@ -6572,109 +6276,11 @@
           <a:p>
             <a:pPr algn="ctr">
               <a:lnSpc>
-                <a:spcPts val="4759"/>
-              </a:lnSpc>
-            </a:pPr>
-            <a:r>
-              <a:rPr lang="en-US" sz="3399">
-                <a:solidFill>
-                  <a:srgbClr val="000000"/>
-                </a:solidFill>
-                <a:latin typeface="Canva Sans"/>
-                <a:ea typeface="Canva Sans"/>
-                <a:cs typeface="Canva Sans"/>
-                <a:sym typeface="Canva Sans"/>
-              </a:rPr>
-              <a:t>The framework </a:t>
-            </a:r>
-            <a:r>
-              <a:rPr lang="en-US" sz="3399">
-                <a:solidFill>
-                  <a:srgbClr val="000000"/>
-                </a:solidFill>
-                <a:latin typeface="Canva Sans"/>
-                <a:ea typeface="Canva Sans"/>
-                <a:cs typeface="Canva Sans"/>
-                <a:sym typeface="Canva Sans"/>
-              </a:rPr>
-              <a:t>didn't do anything conceptually different — it automated </a:t>
-            </a:r>
-          </a:p>
-          <a:p>
-            <a:pPr algn="ctr">
-              <a:lnSpc>
-                <a:spcPts val="4759"/>
-              </a:lnSpc>
-            </a:pPr>
-            <a:r>
-              <a:rPr lang="en-US" sz="3399">
-                <a:solidFill>
-                  <a:srgbClr val="000000"/>
-                </a:solidFill>
-                <a:latin typeface="Canva Sans"/>
-                <a:ea typeface="Canva Sans"/>
-                <a:cs typeface="Canva Sans"/>
-                <a:sym typeface="Canva Sans"/>
-              </a:rPr>
-              <a:t>the exact same chain-rule computations, which is why doing it by hand first made the framework version make sense rather than feel like magic.</a:t>
-            </a:r>
-          </a:p>
-          <a:p>
-            <a:pPr algn="ctr">
-              <a:lnSpc>
-                <a:spcPts val="4759"/>
-              </a:lnSpc>
-            </a:pPr>
-          </a:p>
-          <a:p>
-            <a:pPr algn="ctr">
-              <a:lnSpc>
-                <a:spcPts val="4759"/>
-              </a:lnSpc>
-            </a:pPr>
-            <a:r>
-              <a:rPr lang="en-US" sz="3399">
-                <a:solidFill>
-                  <a:srgbClr val="000000"/>
-                </a:solidFill>
-                <a:latin typeface="Canva Sans"/>
-                <a:ea typeface="Canva Sans"/>
-                <a:cs typeface="Canva Sans"/>
-                <a:sym typeface="Canva Sans"/>
-              </a:rPr>
-              <a:t>~Some LLM</a:t>
-            </a:r>
-          </a:p>
-        </p:txBody>
-      </p:sp>
-      <p:sp>
-        <p:nvSpPr>
-          <p:cNvPr name="TextBox 3" id="3"/>
-          <p:cNvSpPr txBox="true"/>
-          <p:nvPr/>
-        </p:nvSpPr>
-        <p:spPr>
-          <a:xfrm rot="0">
-            <a:off x="4687156" y="1890809"/>
-            <a:ext cx="8913688" cy="1866275"/>
-          </a:xfrm>
-          <a:prstGeom prst="rect">
-            <a:avLst/>
-          </a:prstGeom>
-        </p:spPr>
-        <p:txBody>
-          <a:bodyPr anchor="t" rtlCol="false" tIns="0" lIns="0" bIns="0" rIns="0">
-            <a:spAutoFit/>
-          </a:bodyPr>
-          <a:lstStyle/>
-          <a:p>
-            <a:pPr algn="ctr">
-              <a:lnSpc>
-                <a:spcPts val="15259"/>
-              </a:lnSpc>
-            </a:pPr>
-            <a:r>
-              <a:rPr lang="en-US" sz="10899" b="true">
+                <a:spcPts val="7279"/>
+              </a:lnSpc>
+            </a:pPr>
+            <a:r>
+              <a:rPr lang="en-US" sz="5199" b="true">
                 <a:solidFill>
                   <a:srgbClr val="000000"/>
                 </a:solidFill>
@@ -6683,7 +6289,615 @@
                 <a:cs typeface="Canva Sans Bold"/>
                 <a:sym typeface="Canva Sans Bold"/>
               </a:rPr>
-              <a:t>THANK YOU !</a:t>
+              <a:t>Scratch Implementaion</a:t>
+            </a:r>
+          </a:p>
+        </p:txBody>
+      </p:sp>
+      <p:sp>
+        <p:nvSpPr>
+          <p:cNvPr name="TextBox 3" id="3"/>
+          <p:cNvSpPr txBox="true"/>
+          <p:nvPr/>
+        </p:nvSpPr>
+        <p:spPr>
+          <a:xfrm rot="0">
+            <a:off x="8953301" y="1047869"/>
+            <a:ext cx="8953723" cy="887095"/>
+          </a:xfrm>
+          <a:prstGeom prst="rect">
+            <a:avLst/>
+          </a:prstGeom>
+        </p:spPr>
+        <p:txBody>
+          <a:bodyPr anchor="t" rtlCol="false" tIns="0" lIns="0" bIns="0" rIns="0">
+            <a:spAutoFit/>
+          </a:bodyPr>
+          <a:lstStyle/>
+          <a:p>
+            <a:pPr algn="ctr">
+              <a:lnSpc>
+                <a:spcPts val="7279"/>
+              </a:lnSpc>
+            </a:pPr>
+            <a:r>
+              <a:rPr lang="en-US" sz="5199" b="true">
+                <a:solidFill>
+                  <a:srgbClr val="000000"/>
+                </a:solidFill>
+                <a:latin typeface="Canva Sans Bold"/>
+                <a:ea typeface="Canva Sans Bold"/>
+                <a:cs typeface="Canva Sans Bold"/>
+                <a:sym typeface="Canva Sans Bold"/>
+              </a:rPr>
+              <a:t>Framework Implementation</a:t>
+            </a:r>
+          </a:p>
+        </p:txBody>
+      </p:sp>
+      <p:sp>
+        <p:nvSpPr>
+          <p:cNvPr name="AutoShape 4" id="4"/>
+          <p:cNvSpPr/>
+          <p:nvPr/>
+        </p:nvSpPr>
+        <p:spPr>
+          <a:xfrm>
+            <a:off x="8590974" y="1143119"/>
+            <a:ext cx="0" cy="8115181"/>
+          </a:xfrm>
+          <a:prstGeom prst="line">
+            <a:avLst/>
+          </a:prstGeom>
+          <a:ln cap="flat" w="38100">
+            <a:solidFill>
+              <a:srgbClr val="000000"/>
+            </a:solidFill>
+            <a:prstDash val="solid"/>
+            <a:headEnd type="none" len="sm" w="sm"/>
+            <a:tailEnd type="none" len="sm" w="sm"/>
+          </a:ln>
+        </p:spPr>
+      </p:sp>
+      <p:sp>
+        <p:nvSpPr>
+          <p:cNvPr name="TextBox 5" id="5"/>
+          <p:cNvSpPr txBox="true"/>
+          <p:nvPr/>
+        </p:nvSpPr>
+        <p:spPr>
+          <a:xfrm rot="0">
+            <a:off x="831219" y="2340885"/>
+            <a:ext cx="5242620" cy="1180465"/>
+          </a:xfrm>
+          <a:prstGeom prst="rect">
+            <a:avLst/>
+          </a:prstGeom>
+        </p:spPr>
+        <p:txBody>
+          <a:bodyPr anchor="t" rtlCol="false" tIns="0" lIns="0" bIns="0" rIns="0">
+            <a:spAutoFit/>
+          </a:bodyPr>
+          <a:lstStyle/>
+          <a:p>
+            <a:pPr algn="ctr">
+              <a:lnSpc>
+                <a:spcPts val="4759"/>
+              </a:lnSpc>
+            </a:pPr>
+            <a:r>
+              <a:rPr lang="en-US" sz="3399">
+                <a:solidFill>
+                  <a:srgbClr val="000000"/>
+                </a:solidFill>
+                <a:latin typeface="Canva Sans"/>
+                <a:ea typeface="Canva Sans"/>
+                <a:cs typeface="Canva Sans"/>
+                <a:sym typeface="Canva Sans"/>
+              </a:rPr>
+              <a:t>Max accuracy: 98.0556 %</a:t>
+            </a:r>
+          </a:p>
+          <a:p>
+            <a:pPr algn="ctr">
+              <a:lnSpc>
+                <a:spcPts val="4759"/>
+              </a:lnSpc>
+            </a:pPr>
+            <a:r>
+              <a:rPr lang="en-US" sz="3399">
+                <a:solidFill>
+                  <a:srgbClr val="000000"/>
+                </a:solidFill>
+                <a:latin typeface="Canva Sans"/>
+                <a:ea typeface="Canva Sans"/>
+                <a:cs typeface="Canva Sans"/>
+                <a:sym typeface="Canva Sans"/>
+              </a:rPr>
+              <a:t>Most of the time: ~97.5%</a:t>
+            </a:r>
+          </a:p>
+        </p:txBody>
+      </p:sp>
+      <p:sp>
+        <p:nvSpPr>
+          <p:cNvPr name="TextBox 6" id="6"/>
+          <p:cNvSpPr txBox="true"/>
+          <p:nvPr/>
+        </p:nvSpPr>
+        <p:spPr>
+          <a:xfrm rot="0">
+            <a:off x="9801330" y="2384065"/>
+            <a:ext cx="5245373" cy="1180465"/>
+          </a:xfrm>
+          <a:prstGeom prst="rect">
+            <a:avLst/>
+          </a:prstGeom>
+        </p:spPr>
+        <p:txBody>
+          <a:bodyPr anchor="t" rtlCol="false" tIns="0" lIns="0" bIns="0" rIns="0">
+            <a:spAutoFit/>
+          </a:bodyPr>
+          <a:lstStyle/>
+          <a:p>
+            <a:pPr algn="ctr">
+              <a:lnSpc>
+                <a:spcPts val="4759"/>
+              </a:lnSpc>
+            </a:pPr>
+            <a:r>
+              <a:rPr lang="en-US" sz="3399">
+                <a:solidFill>
+                  <a:srgbClr val="000000"/>
+                </a:solidFill>
+                <a:latin typeface="Canva Sans"/>
+                <a:ea typeface="Canva Sans"/>
+                <a:cs typeface="Canva Sans"/>
+                <a:sym typeface="Canva Sans"/>
+              </a:rPr>
+              <a:t>Max accuracy: 98.33%</a:t>
+            </a:r>
+          </a:p>
+          <a:p>
+            <a:pPr algn="ctr">
+              <a:lnSpc>
+                <a:spcPts val="4759"/>
+              </a:lnSpc>
+            </a:pPr>
+            <a:r>
+              <a:rPr lang="en-US" sz="3399">
+                <a:solidFill>
+                  <a:srgbClr val="000000"/>
+                </a:solidFill>
+                <a:latin typeface="Canva Sans"/>
+                <a:ea typeface="Canva Sans"/>
+                <a:cs typeface="Canva Sans"/>
+                <a:sym typeface="Canva Sans"/>
+              </a:rPr>
+              <a:t>Most of the time: ~97.78%</a:t>
+            </a:r>
+          </a:p>
+        </p:txBody>
+      </p:sp>
+      <p:sp>
+        <p:nvSpPr>
+          <p:cNvPr name="TextBox 7" id="7"/>
+          <p:cNvSpPr txBox="true"/>
+          <p:nvPr/>
+        </p:nvSpPr>
+        <p:spPr>
+          <a:xfrm rot="0">
+            <a:off x="922384" y="3933804"/>
+            <a:ext cx="3833440" cy="580390"/>
+          </a:xfrm>
+          <a:prstGeom prst="rect">
+            <a:avLst/>
+          </a:prstGeom>
+        </p:spPr>
+        <p:txBody>
+          <a:bodyPr anchor="t" rtlCol="false" tIns="0" lIns="0" bIns="0" rIns="0">
+            <a:spAutoFit/>
+          </a:bodyPr>
+          <a:lstStyle/>
+          <a:p>
+            <a:pPr algn="l">
+              <a:lnSpc>
+                <a:spcPts val="4759"/>
+              </a:lnSpc>
+            </a:pPr>
+            <a:r>
+              <a:rPr lang="en-US" sz="3399">
+                <a:solidFill>
+                  <a:srgbClr val="000000"/>
+                </a:solidFill>
+                <a:latin typeface="Canva Sans"/>
+                <a:ea typeface="Canva Sans"/>
+                <a:cs typeface="Canva Sans"/>
+                <a:sym typeface="Canva Sans"/>
+              </a:rPr>
+              <a:t>More lines of code</a:t>
+            </a:r>
+          </a:p>
+        </p:txBody>
+      </p:sp>
+      <p:sp>
+        <p:nvSpPr>
+          <p:cNvPr name="TextBox 8" id="8"/>
+          <p:cNvSpPr txBox="true"/>
+          <p:nvPr/>
+        </p:nvSpPr>
+        <p:spPr>
+          <a:xfrm rot="0">
+            <a:off x="9801330" y="3933804"/>
+            <a:ext cx="5848127" cy="580390"/>
+          </a:xfrm>
+          <a:prstGeom prst="rect">
+            <a:avLst/>
+          </a:prstGeom>
+        </p:spPr>
+        <p:txBody>
+          <a:bodyPr anchor="t" rtlCol="false" tIns="0" lIns="0" bIns="0" rIns="0">
+            <a:spAutoFit/>
+          </a:bodyPr>
+          <a:lstStyle/>
+          <a:p>
+            <a:pPr algn="l">
+              <a:lnSpc>
+                <a:spcPts val="4759"/>
+              </a:lnSpc>
+            </a:pPr>
+            <a:r>
+              <a:rPr lang="en-US" sz="3399">
+                <a:solidFill>
+                  <a:srgbClr val="000000"/>
+                </a:solidFill>
+                <a:latin typeface="Canva Sans"/>
+                <a:ea typeface="Canva Sans"/>
+                <a:cs typeface="Canva Sans"/>
+                <a:sym typeface="Canva Sans"/>
+              </a:rPr>
+              <a:t>2 to 3 times less line of code</a:t>
+            </a:r>
+          </a:p>
+        </p:txBody>
+      </p:sp>
+      <p:sp>
+        <p:nvSpPr>
+          <p:cNvPr name="TextBox 9" id="9"/>
+          <p:cNvSpPr txBox="true"/>
+          <p:nvPr/>
+        </p:nvSpPr>
+        <p:spPr>
+          <a:xfrm rot="0">
+            <a:off x="831219" y="4923769"/>
+            <a:ext cx="5619676" cy="1180465"/>
+          </a:xfrm>
+          <a:prstGeom prst="rect">
+            <a:avLst/>
+          </a:prstGeom>
+        </p:spPr>
+        <p:txBody>
+          <a:bodyPr anchor="t" rtlCol="false" tIns="0" lIns="0" bIns="0" rIns="0">
+            <a:spAutoFit/>
+          </a:bodyPr>
+          <a:lstStyle/>
+          <a:p>
+            <a:pPr algn="ctr">
+              <a:lnSpc>
+                <a:spcPts val="4759"/>
+              </a:lnSpc>
+            </a:pPr>
+            <a:r>
+              <a:rPr lang="en-US" sz="3399">
+                <a:solidFill>
+                  <a:srgbClr val="000000"/>
+                </a:solidFill>
+                <a:latin typeface="Canva Sans"/>
+                <a:ea typeface="Canva Sans"/>
+                <a:cs typeface="Canva Sans"/>
+                <a:sym typeface="Canva Sans"/>
+              </a:rPr>
+              <a:t>No optimization untill  self-</a:t>
+            </a:r>
+          </a:p>
+          <a:p>
+            <a:pPr algn="ctr">
+              <a:lnSpc>
+                <a:spcPts val="4759"/>
+              </a:lnSpc>
+            </a:pPr>
+            <a:r>
+              <a:rPr lang="en-US" sz="3399">
+                <a:solidFill>
+                  <a:srgbClr val="000000"/>
+                </a:solidFill>
+                <a:latin typeface="Canva Sans"/>
+                <a:ea typeface="Canva Sans"/>
+                <a:cs typeface="Canva Sans"/>
+                <a:sym typeface="Canva Sans"/>
+              </a:rPr>
+              <a:t>implemented from scratch</a:t>
+            </a:r>
+          </a:p>
+        </p:txBody>
+      </p:sp>
+      <p:sp>
+        <p:nvSpPr>
+          <p:cNvPr name="TextBox 10" id="10"/>
+          <p:cNvSpPr txBox="true"/>
+          <p:nvPr/>
+        </p:nvSpPr>
+        <p:spPr>
+          <a:xfrm rot="0">
+            <a:off x="9801330" y="4880590"/>
+            <a:ext cx="8486670" cy="1780540"/>
+          </a:xfrm>
+          <a:prstGeom prst="rect">
+            <a:avLst/>
+          </a:prstGeom>
+        </p:spPr>
+        <p:txBody>
+          <a:bodyPr anchor="t" rtlCol="false" tIns="0" lIns="0" bIns="0" rIns="0">
+            <a:spAutoFit/>
+          </a:bodyPr>
+          <a:lstStyle/>
+          <a:p>
+            <a:pPr algn="l">
+              <a:lnSpc>
+                <a:spcPts val="4759"/>
+              </a:lnSpc>
+            </a:pPr>
+            <a:r>
+              <a:rPr lang="en-US" sz="3399">
+                <a:solidFill>
+                  <a:srgbClr val="000000"/>
+                </a:solidFill>
+                <a:latin typeface="Canva Sans"/>
+                <a:ea typeface="Canva Sans"/>
+                <a:cs typeface="Canva Sans"/>
+                <a:sym typeface="Canva Sans"/>
+              </a:rPr>
+              <a:t>Automatic optimization in many ways,</a:t>
+            </a:r>
+          </a:p>
+          <a:p>
+            <a:pPr algn="l">
+              <a:lnSpc>
+                <a:spcPts val="4759"/>
+              </a:lnSpc>
+            </a:pPr>
+            <a:r>
+              <a:rPr lang="en-US" sz="3399">
+                <a:solidFill>
+                  <a:srgbClr val="000000"/>
+                </a:solidFill>
+                <a:latin typeface="Canva Sans"/>
+                <a:ea typeface="Canva Sans"/>
+                <a:cs typeface="Canva Sans"/>
+                <a:sym typeface="Canva Sans"/>
+              </a:rPr>
+              <a:t>in training, in data handling, in calculation, etc.</a:t>
+            </a:r>
+          </a:p>
+        </p:txBody>
+      </p:sp>
+      <p:sp>
+        <p:nvSpPr>
+          <p:cNvPr name="TextBox 11" id="11"/>
+          <p:cNvSpPr txBox="true"/>
+          <p:nvPr/>
+        </p:nvSpPr>
+        <p:spPr>
+          <a:xfrm rot="0">
+            <a:off x="831219" y="6594455"/>
+            <a:ext cx="4733851" cy="580390"/>
+          </a:xfrm>
+          <a:prstGeom prst="rect">
+            <a:avLst/>
+          </a:prstGeom>
+        </p:spPr>
+        <p:txBody>
+          <a:bodyPr anchor="t" rtlCol="false" tIns="0" lIns="0" bIns="0" rIns="0">
+            <a:spAutoFit/>
+          </a:bodyPr>
+          <a:lstStyle/>
+          <a:p>
+            <a:pPr algn="l">
+              <a:lnSpc>
+                <a:spcPts val="4759"/>
+              </a:lnSpc>
+            </a:pPr>
+            <a:r>
+              <a:rPr lang="en-US" sz="3399">
+                <a:solidFill>
+                  <a:srgbClr val="000000"/>
+                </a:solidFill>
+                <a:latin typeface="Canva Sans"/>
+                <a:ea typeface="Canva Sans"/>
+                <a:cs typeface="Canva Sans"/>
+                <a:sym typeface="Canva Sans"/>
+              </a:rPr>
+              <a:t>Less memory efficient.</a:t>
+            </a:r>
+          </a:p>
+        </p:txBody>
+      </p:sp>
+      <p:sp>
+        <p:nvSpPr>
+          <p:cNvPr name="TextBox 12" id="12"/>
+          <p:cNvSpPr txBox="true"/>
+          <p:nvPr/>
+        </p:nvSpPr>
+        <p:spPr>
+          <a:xfrm rot="0">
+            <a:off x="9801330" y="6877685"/>
+            <a:ext cx="8105694" cy="1180465"/>
+          </a:xfrm>
+          <a:prstGeom prst="rect">
+            <a:avLst/>
+          </a:prstGeom>
+        </p:spPr>
+        <p:txBody>
+          <a:bodyPr anchor="t" rtlCol="false" tIns="0" lIns="0" bIns="0" rIns="0">
+            <a:spAutoFit/>
+          </a:bodyPr>
+          <a:lstStyle/>
+          <a:p>
+            <a:pPr algn="l">
+              <a:lnSpc>
+                <a:spcPts val="4759"/>
+              </a:lnSpc>
+            </a:pPr>
+            <a:r>
+              <a:rPr lang="en-US" sz="3399">
+                <a:solidFill>
+                  <a:srgbClr val="000000"/>
+                </a:solidFill>
+                <a:latin typeface="Canva Sans"/>
+                <a:ea typeface="Canva Sans"/>
+                <a:cs typeface="Canva Sans"/>
+                <a:sym typeface="Canva Sans"/>
+              </a:rPr>
+              <a:t>More memory efficient because of optimized code and implementation</a:t>
+            </a:r>
+          </a:p>
+        </p:txBody>
+      </p:sp>
+      <p:sp>
+        <p:nvSpPr>
+          <p:cNvPr name="TextBox 13" id="13"/>
+          <p:cNvSpPr txBox="true"/>
+          <p:nvPr/>
+        </p:nvSpPr>
+        <p:spPr>
+          <a:xfrm rot="0">
+            <a:off x="665945" y="7434580"/>
+            <a:ext cx="7786836" cy="1780540"/>
+          </a:xfrm>
+          <a:prstGeom prst="rect">
+            <a:avLst/>
+          </a:prstGeom>
+        </p:spPr>
+        <p:txBody>
+          <a:bodyPr anchor="t" rtlCol="false" tIns="0" lIns="0" bIns="0" rIns="0">
+            <a:spAutoFit/>
+          </a:bodyPr>
+          <a:lstStyle/>
+          <a:p>
+            <a:pPr algn="l">
+              <a:lnSpc>
+                <a:spcPts val="4759"/>
+              </a:lnSpc>
+            </a:pPr>
+            <a:r>
+              <a:rPr lang="en-US" sz="3399">
+                <a:solidFill>
+                  <a:srgbClr val="000000"/>
+                </a:solidFill>
+                <a:latin typeface="Canva Sans"/>
+                <a:ea typeface="Canva Sans"/>
+                <a:cs typeface="Canva Sans"/>
+                <a:sym typeface="Canva Sans"/>
+              </a:rPr>
+              <a:t>This implementation is made for only</a:t>
+            </a:r>
+          </a:p>
+          <a:p>
+            <a:pPr algn="l">
+              <a:lnSpc>
+                <a:spcPts val="4759"/>
+              </a:lnSpc>
+            </a:pPr>
+            <a:r>
+              <a:rPr lang="en-US" sz="3399">
+                <a:solidFill>
+                  <a:srgbClr val="000000"/>
+                </a:solidFill>
+                <a:latin typeface="Canva Sans"/>
+                <a:ea typeface="Canva Sans"/>
+                <a:cs typeface="Canva Sans"/>
+                <a:sym typeface="Canva Sans"/>
+              </a:rPr>
+              <a:t>this type of model, with crossentropy</a:t>
+            </a:r>
+          </a:p>
+          <a:p>
+            <a:pPr algn="l">
+              <a:lnSpc>
+                <a:spcPts val="4759"/>
+              </a:lnSpc>
+            </a:pPr>
+            <a:r>
+              <a:rPr lang="en-US" sz="3399">
+                <a:solidFill>
+                  <a:srgbClr val="000000"/>
+                </a:solidFill>
+                <a:latin typeface="Canva Sans"/>
+                <a:ea typeface="Canva Sans"/>
+                <a:cs typeface="Canva Sans"/>
+                <a:sym typeface="Canva Sans"/>
+              </a:rPr>
+              <a:t>loss, relu and softmax activation.</a:t>
+            </a:r>
+          </a:p>
+        </p:txBody>
+      </p:sp>
+      <p:sp>
+        <p:nvSpPr>
+          <p:cNvPr name="TextBox 14" id="14"/>
+          <p:cNvSpPr txBox="true"/>
+          <p:nvPr/>
+        </p:nvSpPr>
+        <p:spPr>
+          <a:xfrm rot="0">
+            <a:off x="9801330" y="8277225"/>
+            <a:ext cx="7578179" cy="1180465"/>
+          </a:xfrm>
+          <a:prstGeom prst="rect">
+            <a:avLst/>
+          </a:prstGeom>
+        </p:spPr>
+        <p:txBody>
+          <a:bodyPr anchor="t" rtlCol="false" tIns="0" lIns="0" bIns="0" rIns="0">
+            <a:spAutoFit/>
+          </a:bodyPr>
+          <a:lstStyle/>
+          <a:p>
+            <a:pPr algn="l">
+              <a:lnSpc>
+                <a:spcPts val="4759"/>
+              </a:lnSpc>
+            </a:pPr>
+            <a:r>
+              <a:rPr lang="en-US" sz="3399">
+                <a:solidFill>
+                  <a:srgbClr val="000000"/>
+                </a:solidFill>
+                <a:latin typeface="Canva Sans"/>
+                <a:ea typeface="Canva Sans"/>
+                <a:cs typeface="Canva Sans"/>
+                <a:sym typeface="Canva Sans"/>
+              </a:rPr>
+              <a:t>Works for all types of activation and </a:t>
+            </a:r>
+          </a:p>
+          <a:p>
+            <a:pPr algn="l">
+              <a:lnSpc>
+                <a:spcPts val="4759"/>
+              </a:lnSpc>
+            </a:pPr>
+            <a:r>
+              <a:rPr lang="en-US" sz="3399">
+                <a:solidFill>
+                  <a:srgbClr val="000000"/>
+                </a:solidFill>
+                <a:latin typeface="Canva Sans"/>
+                <a:ea typeface="Canva Sans"/>
+                <a:cs typeface="Canva Sans"/>
+                <a:sym typeface="Canva Sans"/>
+              </a:rPr>
+              <a:t>loss function with better options.</a:t>
             </a:r>
           </a:p>
         </p:txBody>
@@ -7010,6 +7224,170 @@
 </p:sld>
 </file>
 
+<file path=ppt/slides/slide20.xml><?xml version="1.0" encoding="utf-8"?>
+<p:sld xmlns:p="http://schemas.openxmlformats.org/presentationml/2006/main" xmlns:a="http://schemas.openxmlformats.org/drawingml/2006/main">
+  <p:cSld>
+    <p:spTree>
+      <p:nvGrpSpPr>
+        <p:cNvPr id="1" name=""/>
+        <p:cNvGrpSpPr/>
+        <p:nvPr/>
+      </p:nvGrpSpPr>
+      <p:grpSpPr>
+        <a:xfrm>
+          <a:off x="0" y="0"/>
+          <a:ext cx="0" cy="0"/>
+          <a:chOff x="0" y="0"/>
+          <a:chExt cx="0" cy="0"/>
+        </a:xfrm>
+      </p:grpSpPr>
+      <p:sp>
+        <p:nvSpPr>
+          <p:cNvPr name="TextBox 2" id="2"/>
+          <p:cNvSpPr txBox="true"/>
+          <p:nvPr/>
+        </p:nvSpPr>
+        <p:spPr>
+          <a:xfrm rot="0">
+            <a:off x="0" y="4819967"/>
+            <a:ext cx="18288000" cy="2980690"/>
+          </a:xfrm>
+          <a:prstGeom prst="rect">
+            <a:avLst/>
+          </a:prstGeom>
+        </p:spPr>
+        <p:txBody>
+          <a:bodyPr anchor="t" rtlCol="false" tIns="0" lIns="0" bIns="0" rIns="0">
+            <a:spAutoFit/>
+          </a:bodyPr>
+          <a:lstStyle/>
+          <a:p>
+            <a:pPr algn="ctr">
+              <a:lnSpc>
+                <a:spcPts val="4759"/>
+              </a:lnSpc>
+            </a:pPr>
+            <a:r>
+              <a:rPr lang="en-US" sz="3399">
+                <a:solidFill>
+                  <a:srgbClr val="000000"/>
+                </a:solidFill>
+                <a:latin typeface="Canva Sans"/>
+                <a:ea typeface="Canva Sans"/>
+                <a:cs typeface="Canva Sans"/>
+                <a:sym typeface="Canva Sans"/>
+              </a:rPr>
+              <a:t>The framework </a:t>
+            </a:r>
+            <a:r>
+              <a:rPr lang="en-US" sz="3399">
+                <a:solidFill>
+                  <a:srgbClr val="000000"/>
+                </a:solidFill>
+                <a:latin typeface="Canva Sans"/>
+                <a:ea typeface="Canva Sans"/>
+                <a:cs typeface="Canva Sans"/>
+                <a:sym typeface="Canva Sans"/>
+              </a:rPr>
+              <a:t>didn't do anything conceptually different — it automated </a:t>
+            </a:r>
+          </a:p>
+          <a:p>
+            <a:pPr algn="ctr">
+              <a:lnSpc>
+                <a:spcPts val="4759"/>
+              </a:lnSpc>
+            </a:pPr>
+            <a:r>
+              <a:rPr lang="en-US" sz="3399">
+                <a:solidFill>
+                  <a:srgbClr val="000000"/>
+                </a:solidFill>
+                <a:latin typeface="Canva Sans"/>
+                <a:ea typeface="Canva Sans"/>
+                <a:cs typeface="Canva Sans"/>
+                <a:sym typeface="Canva Sans"/>
+              </a:rPr>
+              <a:t>the exact same chain-rule computations, which is why doing it by hand first made the framework version make sense rather than feel like magic.</a:t>
+            </a:r>
+          </a:p>
+          <a:p>
+            <a:pPr algn="ctr">
+              <a:lnSpc>
+                <a:spcPts val="4759"/>
+              </a:lnSpc>
+            </a:pPr>
+          </a:p>
+          <a:p>
+            <a:pPr algn="ctr">
+              <a:lnSpc>
+                <a:spcPts val="4759"/>
+              </a:lnSpc>
+            </a:pPr>
+            <a:r>
+              <a:rPr lang="en-US" sz="3399">
+                <a:solidFill>
+                  <a:srgbClr val="000000"/>
+                </a:solidFill>
+                <a:latin typeface="Canva Sans"/>
+                <a:ea typeface="Canva Sans"/>
+                <a:cs typeface="Canva Sans"/>
+                <a:sym typeface="Canva Sans"/>
+              </a:rPr>
+              <a:t>~Some LLM</a:t>
+            </a:r>
+          </a:p>
+        </p:txBody>
+      </p:sp>
+      <p:sp>
+        <p:nvSpPr>
+          <p:cNvPr name="TextBox 3" id="3"/>
+          <p:cNvSpPr txBox="true"/>
+          <p:nvPr/>
+        </p:nvSpPr>
+        <p:spPr>
+          <a:xfrm rot="0">
+            <a:off x="4687156" y="1890809"/>
+            <a:ext cx="8913688" cy="1866275"/>
+          </a:xfrm>
+          <a:prstGeom prst="rect">
+            <a:avLst/>
+          </a:prstGeom>
+        </p:spPr>
+        <p:txBody>
+          <a:bodyPr anchor="t" rtlCol="false" tIns="0" lIns="0" bIns="0" rIns="0">
+            <a:spAutoFit/>
+          </a:bodyPr>
+          <a:lstStyle/>
+          <a:p>
+            <a:pPr algn="ctr">
+              <a:lnSpc>
+                <a:spcPts val="15259"/>
+              </a:lnSpc>
+            </a:pPr>
+            <a:r>
+              <a:rPr lang="en-US" sz="10899" b="true">
+                <a:solidFill>
+                  <a:srgbClr val="000000"/>
+                </a:solidFill>
+                <a:latin typeface="Canva Sans Bold"/>
+                <a:ea typeface="Canva Sans Bold"/>
+                <a:cs typeface="Canva Sans Bold"/>
+                <a:sym typeface="Canva Sans Bold"/>
+              </a:rPr>
+              <a:t>THANK YOU !</a:t>
+            </a:r>
+          </a:p>
+        </p:txBody>
+      </p:sp>
+    </p:spTree>
+  </p:cSld>
+  <p:clrMapOvr>
+    <a:masterClrMapping/>
+  </p:clrMapOvr>
+</p:sld>
+</file>
+
 <file path=ppt/slides/slide3.xml><?xml version="1.0" encoding="utf-8"?>
 <p:sld xmlns:p="http://schemas.openxmlformats.org/presentationml/2006/main" xmlns:a="http://schemas.openxmlformats.org/drawingml/2006/main" xmlns:r="http://schemas.openxmlformats.org/officeDocument/2006/relationships">
   <p:cSld>
@@ -7487,6 +7865,799 @@
         </p:nvSpPr>
         <p:spPr>
           <a:xfrm flipH="false" flipV="false" rot="0">
+            <a:off x="5995478" y="5143500"/>
+            <a:ext cx="11978635" cy="4810775"/>
+          </a:xfrm>
+          <a:custGeom>
+            <a:avLst/>
+            <a:gdLst/>
+            <a:ahLst/>
+            <a:cxnLst/>
+            <a:rect r="r" b="b" t="t" l="l"/>
+            <a:pathLst>
+              <a:path h="4810775" w="11978635">
+                <a:moveTo>
+                  <a:pt x="0" y="0"/>
+                </a:moveTo>
+                <a:lnTo>
+                  <a:pt x="11978635" y="0"/>
+                </a:lnTo>
+                <a:lnTo>
+                  <a:pt x="11978635" y="4810775"/>
+                </a:lnTo>
+                <a:lnTo>
+                  <a:pt x="0" y="4810775"/>
+                </a:lnTo>
+                <a:lnTo>
+                  <a:pt x="0" y="0"/>
+                </a:lnTo>
+                <a:close/>
+              </a:path>
+            </a:pathLst>
+          </a:custGeom>
+          <a:blipFill>
+            <a:blip r:embed="rId2"/>
+            <a:stretch>
+              <a:fillRect l="0" t="0" r="0" b="0"/>
+            </a:stretch>
+          </a:blipFill>
+        </p:spPr>
+      </p:sp>
+      <p:sp>
+        <p:nvSpPr>
+          <p:cNvPr name="Freeform 3" id="3"/>
+          <p:cNvSpPr/>
+          <p:nvPr/>
+        </p:nvSpPr>
+        <p:spPr>
+          <a:xfrm flipH="false" flipV="false" rot="0">
+            <a:off x="180762" y="8353327"/>
+            <a:ext cx="5664890" cy="1600947"/>
+          </a:xfrm>
+          <a:custGeom>
+            <a:avLst/>
+            <a:gdLst/>
+            <a:ahLst/>
+            <a:cxnLst/>
+            <a:rect r="r" b="b" t="t" l="l"/>
+            <a:pathLst>
+              <a:path h="1600947" w="5664890">
+                <a:moveTo>
+                  <a:pt x="0" y="0"/>
+                </a:moveTo>
+                <a:lnTo>
+                  <a:pt x="5664890" y="0"/>
+                </a:lnTo>
+                <a:lnTo>
+                  <a:pt x="5664890" y="1600948"/>
+                </a:lnTo>
+                <a:lnTo>
+                  <a:pt x="0" y="1600948"/>
+                </a:lnTo>
+                <a:lnTo>
+                  <a:pt x="0" y="0"/>
+                </a:lnTo>
+                <a:close/>
+              </a:path>
+            </a:pathLst>
+          </a:custGeom>
+          <a:blipFill>
+            <a:blip r:embed="rId3"/>
+            <a:stretch>
+              <a:fillRect l="0" t="0" r="0" b="0"/>
+            </a:stretch>
+          </a:blipFill>
+        </p:spPr>
+      </p:sp>
+      <p:sp>
+        <p:nvSpPr>
+          <p:cNvPr name="TextBox 4" id="4"/>
+          <p:cNvSpPr txBox="true"/>
+          <p:nvPr/>
+        </p:nvSpPr>
+        <p:spPr>
+          <a:xfrm rot="0">
+            <a:off x="2042926" y="933450"/>
+            <a:ext cx="14202147" cy="887095"/>
+          </a:xfrm>
+          <a:prstGeom prst="rect">
+            <a:avLst/>
+          </a:prstGeom>
+        </p:spPr>
+        <p:txBody>
+          <a:bodyPr anchor="t" rtlCol="false" tIns="0" lIns="0" bIns="0" rIns="0">
+            <a:spAutoFit/>
+          </a:bodyPr>
+          <a:lstStyle/>
+          <a:p>
+            <a:pPr algn="ctr">
+              <a:lnSpc>
+                <a:spcPts val="7279"/>
+              </a:lnSpc>
+            </a:pPr>
+            <a:r>
+              <a:rPr lang="en-US" sz="5199" b="true">
+                <a:solidFill>
+                  <a:srgbClr val="000000"/>
+                </a:solidFill>
+                <a:latin typeface="Canva Sans Bold"/>
+                <a:ea typeface="Canva Sans Bold"/>
+                <a:cs typeface="Canva Sans Bold"/>
+                <a:sym typeface="Canva Sans Bold"/>
+              </a:rPr>
+              <a:t>Weights Initialization (Kaiming Initialization)</a:t>
+            </a:r>
+          </a:p>
+        </p:txBody>
+      </p:sp>
+      <p:sp>
+        <p:nvSpPr>
+          <p:cNvPr name="TextBox 5" id="5"/>
+          <p:cNvSpPr txBox="true"/>
+          <p:nvPr/>
+        </p:nvSpPr>
+        <p:spPr>
+          <a:xfrm rot="0">
+            <a:off x="425488" y="1957297"/>
+            <a:ext cx="17437024" cy="2891769"/>
+          </a:xfrm>
+          <a:prstGeom prst="rect">
+            <a:avLst/>
+          </a:prstGeom>
+        </p:spPr>
+        <p:txBody>
+          <a:bodyPr anchor="t" rtlCol="false" tIns="0" lIns="0" bIns="0" rIns="0">
+            <a:spAutoFit/>
+          </a:bodyPr>
+          <a:lstStyle/>
+          <a:p>
+            <a:pPr algn="l">
+              <a:lnSpc>
+                <a:spcPts val="3886"/>
+              </a:lnSpc>
+            </a:pPr>
+            <a:r>
+              <a:rPr lang="en-US" sz="2775">
+                <a:solidFill>
+                  <a:srgbClr val="000000"/>
+                </a:solidFill>
+                <a:latin typeface="Canva Sans"/>
+                <a:ea typeface="Canva Sans"/>
+                <a:cs typeface="Canva Sans"/>
+                <a:sym typeface="Canva Sans"/>
+              </a:rPr>
+              <a:t>To solve the problem of exploding or vanishing gradients in a neural network, we use different kinds of weights intialization which tends to keep the variance of output of each layer in check by initializing the weights in such a way that the variance of ‘Z’ for each layer remains constant and Z neither explodes or vanishes. In case when we use ReLU activation, we multiply a ‘2’ with the variance, because ReLU on average zeros out half of the inputs, which further pushes down the variance by a factor of two. To compensate this, the 2 is multiplied. Without this 2, it is called ‘Xavier’s initialization’.</a:t>
+            </a:r>
+          </a:p>
+        </p:txBody>
+      </p:sp>
+      <p:sp>
+        <p:nvSpPr>
+          <p:cNvPr name="TextBox 6" id="6"/>
+          <p:cNvSpPr txBox="true"/>
+          <p:nvPr/>
+        </p:nvSpPr>
+        <p:spPr>
+          <a:xfrm rot="0">
+            <a:off x="236530" y="5165329"/>
+            <a:ext cx="5609122" cy="2957830"/>
+          </a:xfrm>
+          <a:prstGeom prst="rect">
+            <a:avLst/>
+          </a:prstGeom>
+        </p:spPr>
+        <p:txBody>
+          <a:bodyPr anchor="t" rtlCol="false" tIns="0" lIns="0" bIns="0" rIns="0">
+            <a:spAutoFit/>
+          </a:bodyPr>
+          <a:lstStyle/>
+          <a:p>
+            <a:pPr algn="l">
+              <a:lnSpc>
+                <a:spcPts val="3920"/>
+              </a:lnSpc>
+            </a:pPr>
+            <a:r>
+              <a:rPr lang="en-US" sz="2800">
+                <a:solidFill>
+                  <a:srgbClr val="000000"/>
+                </a:solidFill>
+                <a:latin typeface="Canva Sans"/>
+                <a:ea typeface="Canva Sans"/>
+                <a:cs typeface="Canva Sans"/>
+                <a:sym typeface="Canva Sans"/>
+              </a:rPr>
+              <a:t>To achieve that, we choose the weights randomly from standard</a:t>
+            </a:r>
+          </a:p>
+          <a:p>
+            <a:pPr algn="l">
+              <a:lnSpc>
+                <a:spcPts val="3920"/>
+              </a:lnSpc>
+            </a:pPr>
+            <a:r>
+              <a:rPr lang="en-US" sz="2800">
+                <a:solidFill>
+                  <a:srgbClr val="000000"/>
+                </a:solidFill>
+                <a:latin typeface="Canva Sans"/>
+                <a:ea typeface="Canva Sans"/>
+                <a:cs typeface="Canva Sans"/>
+                <a:sym typeface="Canva Sans"/>
+              </a:rPr>
+              <a:t>normal distribution and product </a:t>
+            </a:r>
+          </a:p>
+          <a:p>
+            <a:pPr algn="l">
+              <a:lnSpc>
+                <a:spcPts val="3920"/>
+              </a:lnSpc>
+            </a:pPr>
+            <a:r>
+              <a:rPr lang="en-US" sz="2800">
+                <a:solidFill>
+                  <a:srgbClr val="000000"/>
+                </a:solidFill>
+                <a:latin typeface="Canva Sans"/>
+                <a:ea typeface="Canva Sans"/>
+                <a:cs typeface="Canva Sans"/>
+                <a:sym typeface="Canva Sans"/>
+              </a:rPr>
+              <a:t>them with required variance, which helps us to choose weights with specific variance.</a:t>
+            </a:r>
+          </a:p>
+        </p:txBody>
+      </p:sp>
+      <p:grpSp>
+        <p:nvGrpSpPr>
+          <p:cNvPr name="Group 7" id="7"/>
+          <p:cNvGrpSpPr/>
+          <p:nvPr/>
+        </p:nvGrpSpPr>
+        <p:grpSpPr>
+          <a:xfrm rot="0">
+            <a:off x="13796010" y="7228522"/>
+            <a:ext cx="3669030" cy="193358"/>
+            <a:chOff x="0" y="0"/>
+            <a:chExt cx="4892040" cy="257810"/>
+          </a:xfrm>
+        </p:grpSpPr>
+        <p:sp>
+          <p:nvSpPr>
+            <p:cNvPr name="Freeform 8" id="8"/>
+            <p:cNvSpPr/>
+            <p:nvPr/>
+          </p:nvSpPr>
+          <p:spPr>
+            <a:xfrm flipH="false" flipV="false" rot="0">
+              <a:off x="50681" y="50800"/>
+              <a:ext cx="4789430" cy="183312"/>
+            </a:xfrm>
+            <a:custGeom>
+              <a:avLst/>
+              <a:gdLst/>
+              <a:ahLst/>
+              <a:cxnLst/>
+              <a:rect r="r" b="b" t="t" l="l"/>
+              <a:pathLst>
+                <a:path h="183312" w="4789430">
+                  <a:moveTo>
+                    <a:pt x="25519" y="0"/>
+                  </a:moveTo>
+                  <a:cubicBezTo>
+                    <a:pt x="985639" y="6350"/>
+                    <a:pt x="998339" y="19050"/>
+                    <a:pt x="1052949" y="24130"/>
+                  </a:cubicBezTo>
+                  <a:cubicBezTo>
+                    <a:pt x="1145659" y="33020"/>
+                    <a:pt x="1347589" y="19050"/>
+                    <a:pt x="1425059" y="26670"/>
+                  </a:cubicBezTo>
+                  <a:cubicBezTo>
+                    <a:pt x="1460619" y="30480"/>
+                    <a:pt x="1466969" y="38100"/>
+                    <a:pt x="1503799" y="41910"/>
+                  </a:cubicBezTo>
+                  <a:cubicBezTo>
+                    <a:pt x="1578729" y="50800"/>
+                    <a:pt x="1728589" y="44450"/>
+                    <a:pt x="1863209" y="53340"/>
+                  </a:cubicBezTo>
+                  <a:cubicBezTo>
+                    <a:pt x="2033389" y="63500"/>
+                    <a:pt x="2183249" y="92710"/>
+                    <a:pt x="2441059" y="104140"/>
+                  </a:cubicBezTo>
+                  <a:cubicBezTo>
+                    <a:pt x="2955409" y="128270"/>
+                    <a:pt x="4629269" y="72390"/>
+                    <a:pt x="4763889" y="105410"/>
+                  </a:cubicBezTo>
+                  <a:cubicBezTo>
+                    <a:pt x="4777859" y="109220"/>
+                    <a:pt x="4780399" y="110490"/>
+                    <a:pt x="4785479" y="116840"/>
+                  </a:cubicBezTo>
+                  <a:cubicBezTo>
+                    <a:pt x="4789289" y="121920"/>
+                    <a:pt x="4790559" y="133350"/>
+                    <a:pt x="4788019" y="139700"/>
+                  </a:cubicBezTo>
+                  <a:cubicBezTo>
+                    <a:pt x="4785479" y="147320"/>
+                    <a:pt x="4776589" y="153670"/>
+                    <a:pt x="4768969" y="156210"/>
+                  </a:cubicBezTo>
+                  <a:cubicBezTo>
+                    <a:pt x="4762619" y="157480"/>
+                    <a:pt x="4751189" y="153670"/>
+                    <a:pt x="4746109" y="149860"/>
+                  </a:cubicBezTo>
+                  <a:cubicBezTo>
+                    <a:pt x="4741029" y="144780"/>
+                    <a:pt x="4737219" y="133350"/>
+                    <a:pt x="4738489" y="127000"/>
+                  </a:cubicBezTo>
+                  <a:cubicBezTo>
+                    <a:pt x="4739759" y="119380"/>
+                    <a:pt x="4747379" y="110490"/>
+                    <a:pt x="4753729" y="107950"/>
+                  </a:cubicBezTo>
+                  <a:cubicBezTo>
+                    <a:pt x="4760079" y="105410"/>
+                    <a:pt x="4771509" y="105410"/>
+                    <a:pt x="4776589" y="109220"/>
+                  </a:cubicBezTo>
+                  <a:cubicBezTo>
+                    <a:pt x="4782939" y="113030"/>
+                    <a:pt x="4790559" y="121920"/>
+                    <a:pt x="4789289" y="129540"/>
+                  </a:cubicBezTo>
+                  <a:cubicBezTo>
+                    <a:pt x="4788019" y="138430"/>
+                    <a:pt x="4781669" y="148590"/>
+                    <a:pt x="4763889" y="156210"/>
+                  </a:cubicBezTo>
+                  <a:cubicBezTo>
+                    <a:pt x="4626729" y="215900"/>
+                    <a:pt x="3100189" y="158750"/>
+                    <a:pt x="2689979" y="156210"/>
+                  </a:cubicBezTo>
+                  <a:cubicBezTo>
+                    <a:pt x="2517259" y="154940"/>
+                    <a:pt x="2449949" y="158750"/>
+                    <a:pt x="2320409" y="151130"/>
+                  </a:cubicBezTo>
+                  <a:cubicBezTo>
+                    <a:pt x="2175629" y="142240"/>
+                    <a:pt x="1996559" y="111760"/>
+                    <a:pt x="1863209" y="104140"/>
+                  </a:cubicBezTo>
+                  <a:cubicBezTo>
+                    <a:pt x="1759069" y="97790"/>
+                    <a:pt x="1667629" y="104140"/>
+                    <a:pt x="1587619" y="99060"/>
+                  </a:cubicBezTo>
+                  <a:cubicBezTo>
+                    <a:pt x="1526659" y="93980"/>
+                    <a:pt x="1491099" y="81280"/>
+                    <a:pt x="1425059" y="77470"/>
+                  </a:cubicBezTo>
+                  <a:cubicBezTo>
+                    <a:pt x="1325999" y="69850"/>
+                    <a:pt x="1141849" y="83820"/>
+                    <a:pt x="1049139" y="74930"/>
+                  </a:cubicBezTo>
+                  <a:cubicBezTo>
+                    <a:pt x="995799" y="69850"/>
+                    <a:pt x="984369" y="57150"/>
+                    <a:pt x="922139" y="50800"/>
+                  </a:cubicBezTo>
+                  <a:cubicBezTo>
+                    <a:pt x="758309" y="35560"/>
+                    <a:pt x="110609" y="88900"/>
+                    <a:pt x="25519" y="50800"/>
+                  </a:cubicBezTo>
+                  <a:cubicBezTo>
+                    <a:pt x="7739" y="43180"/>
+                    <a:pt x="-1151" y="31750"/>
+                    <a:pt x="119" y="22860"/>
+                  </a:cubicBezTo>
+                  <a:cubicBezTo>
+                    <a:pt x="119" y="13970"/>
+                    <a:pt x="25519" y="0"/>
+                    <a:pt x="25519" y="0"/>
+                  </a:cubicBezTo>
+                </a:path>
+              </a:pathLst>
+            </a:custGeom>
+            <a:solidFill>
+              <a:srgbClr val="0571D3"/>
+            </a:solidFill>
+            <a:ln cap="sq">
+              <a:noFill/>
+              <a:prstDash val="solid"/>
+              <a:miter/>
+            </a:ln>
+          </p:spPr>
+        </p:sp>
+      </p:grpSp>
+      <p:grpSp>
+        <p:nvGrpSpPr>
+          <p:cNvPr name="Group 9" id="9"/>
+          <p:cNvGrpSpPr/>
+          <p:nvPr/>
+        </p:nvGrpSpPr>
+        <p:grpSpPr>
+          <a:xfrm rot="0">
+            <a:off x="12512040" y="8314372"/>
+            <a:ext cx="2977515" cy="233362"/>
+            <a:chOff x="0" y="0"/>
+            <a:chExt cx="3970020" cy="311150"/>
+          </a:xfrm>
+        </p:grpSpPr>
+        <p:sp>
+          <p:nvSpPr>
+            <p:cNvPr name="Freeform 10" id="10"/>
+            <p:cNvSpPr/>
+            <p:nvPr/>
+          </p:nvSpPr>
+          <p:spPr>
+            <a:xfrm flipH="false" flipV="false" rot="0">
+              <a:off x="50800" y="47318"/>
+              <a:ext cx="3868560" cy="238089"/>
+            </a:xfrm>
+            <a:custGeom>
+              <a:avLst/>
+              <a:gdLst/>
+              <a:ahLst/>
+              <a:cxnLst/>
+              <a:rect r="r" b="b" t="t" l="l"/>
+              <a:pathLst>
+                <a:path h="238089" w="3868560">
+                  <a:moveTo>
+                    <a:pt x="25400" y="162232"/>
+                  </a:moveTo>
+                  <a:cubicBezTo>
+                    <a:pt x="1389380" y="155882"/>
+                    <a:pt x="1403350" y="144452"/>
+                    <a:pt x="1452880" y="140642"/>
+                  </a:cubicBezTo>
+                  <a:cubicBezTo>
+                    <a:pt x="1517650" y="134292"/>
+                    <a:pt x="1605280" y="140642"/>
+                    <a:pt x="1682750" y="135562"/>
+                  </a:cubicBezTo>
+                  <a:cubicBezTo>
+                    <a:pt x="1762760" y="130482"/>
+                    <a:pt x="1845310" y="121592"/>
+                    <a:pt x="1925320" y="110162"/>
+                  </a:cubicBezTo>
+                  <a:cubicBezTo>
+                    <a:pt x="2002790" y="97462"/>
+                    <a:pt x="2076450" y="70792"/>
+                    <a:pt x="2153920" y="61902"/>
+                  </a:cubicBezTo>
+                  <a:cubicBezTo>
+                    <a:pt x="2232660" y="53012"/>
+                    <a:pt x="2325370" y="63172"/>
+                    <a:pt x="2393950" y="56822"/>
+                  </a:cubicBezTo>
+                  <a:cubicBezTo>
+                    <a:pt x="2446020" y="51742"/>
+                    <a:pt x="2463800" y="40312"/>
+                    <a:pt x="2531110" y="35232"/>
+                  </a:cubicBezTo>
+                  <a:cubicBezTo>
+                    <a:pt x="2706370" y="21262"/>
+                    <a:pt x="3335020" y="45392"/>
+                    <a:pt x="3500120" y="30152"/>
+                  </a:cubicBezTo>
+                  <a:cubicBezTo>
+                    <a:pt x="3557270" y="25072"/>
+                    <a:pt x="3569970" y="13642"/>
+                    <a:pt x="3614420" y="8562"/>
+                  </a:cubicBezTo>
+                  <a:cubicBezTo>
+                    <a:pt x="3677920" y="2212"/>
+                    <a:pt x="3807460" y="-4138"/>
+                    <a:pt x="3843020" y="3482"/>
+                  </a:cubicBezTo>
+                  <a:cubicBezTo>
+                    <a:pt x="3854450" y="6022"/>
+                    <a:pt x="3859530" y="8562"/>
+                    <a:pt x="3863340" y="14912"/>
+                  </a:cubicBezTo>
+                  <a:cubicBezTo>
+                    <a:pt x="3868420" y="19992"/>
+                    <a:pt x="3869690" y="31422"/>
+                    <a:pt x="3867150" y="37772"/>
+                  </a:cubicBezTo>
+                  <a:cubicBezTo>
+                    <a:pt x="3864610" y="45392"/>
+                    <a:pt x="3855720" y="51742"/>
+                    <a:pt x="3849370" y="54282"/>
+                  </a:cubicBezTo>
+                  <a:cubicBezTo>
+                    <a:pt x="3841750" y="55552"/>
+                    <a:pt x="3831590" y="53012"/>
+                    <a:pt x="3825240" y="47932"/>
+                  </a:cubicBezTo>
+                  <a:cubicBezTo>
+                    <a:pt x="3820160" y="42852"/>
+                    <a:pt x="3816350" y="32692"/>
+                    <a:pt x="3817620" y="25072"/>
+                  </a:cubicBezTo>
+                  <a:cubicBezTo>
+                    <a:pt x="3818890" y="18722"/>
+                    <a:pt x="3825240" y="9832"/>
+                    <a:pt x="3831590" y="6022"/>
+                  </a:cubicBezTo>
+                  <a:cubicBezTo>
+                    <a:pt x="3837940" y="3482"/>
+                    <a:pt x="3849370" y="3482"/>
+                    <a:pt x="3855720" y="7292"/>
+                  </a:cubicBezTo>
+                  <a:cubicBezTo>
+                    <a:pt x="3862070" y="11102"/>
+                    <a:pt x="3869690" y="19992"/>
+                    <a:pt x="3868420" y="27612"/>
+                  </a:cubicBezTo>
+                  <a:cubicBezTo>
+                    <a:pt x="3867150" y="36502"/>
+                    <a:pt x="3858260" y="47932"/>
+                    <a:pt x="3843020" y="54282"/>
+                  </a:cubicBezTo>
+                  <a:cubicBezTo>
+                    <a:pt x="3807460" y="70792"/>
+                    <a:pt x="3683000" y="53012"/>
+                    <a:pt x="3620770" y="59362"/>
+                  </a:cubicBezTo>
+                  <a:cubicBezTo>
+                    <a:pt x="3573780" y="64442"/>
+                    <a:pt x="3559810" y="75872"/>
+                    <a:pt x="3500120" y="80952"/>
+                  </a:cubicBezTo>
+                  <a:cubicBezTo>
+                    <a:pt x="3333750" y="96192"/>
+                    <a:pt x="2713990" y="72062"/>
+                    <a:pt x="2536190" y="86032"/>
+                  </a:cubicBezTo>
+                  <a:cubicBezTo>
+                    <a:pt x="2467610" y="91112"/>
+                    <a:pt x="2451100" y="102542"/>
+                    <a:pt x="2393950" y="107622"/>
+                  </a:cubicBezTo>
+                  <a:cubicBezTo>
+                    <a:pt x="2312670" y="115242"/>
+                    <a:pt x="2175510" y="107622"/>
+                    <a:pt x="2089150" y="119052"/>
+                  </a:cubicBezTo>
+                  <a:cubicBezTo>
+                    <a:pt x="2026920" y="129212"/>
+                    <a:pt x="1987550" y="149532"/>
+                    <a:pt x="1926590" y="159692"/>
+                  </a:cubicBezTo>
+                  <a:cubicBezTo>
+                    <a:pt x="1854200" y="173662"/>
+                    <a:pt x="1762760" y="181282"/>
+                    <a:pt x="1682750" y="186362"/>
+                  </a:cubicBezTo>
+                  <a:cubicBezTo>
+                    <a:pt x="1606550" y="191442"/>
+                    <a:pt x="1522730" y="185092"/>
+                    <a:pt x="1457960" y="191442"/>
+                  </a:cubicBezTo>
+                  <a:cubicBezTo>
+                    <a:pt x="1407160" y="195252"/>
+                    <a:pt x="1391920" y="206682"/>
+                    <a:pt x="1324610" y="213032"/>
+                  </a:cubicBezTo>
+                  <a:cubicBezTo>
+                    <a:pt x="1113790" y="229542"/>
+                    <a:pt x="130810" y="260022"/>
+                    <a:pt x="25400" y="213032"/>
+                  </a:cubicBezTo>
+                  <a:cubicBezTo>
+                    <a:pt x="7620" y="204142"/>
+                    <a:pt x="0" y="192712"/>
+                    <a:pt x="0" y="183822"/>
+                  </a:cubicBezTo>
+                  <a:cubicBezTo>
+                    <a:pt x="1270" y="176202"/>
+                    <a:pt x="25400" y="162232"/>
+                    <a:pt x="25400" y="162232"/>
+                  </a:cubicBezTo>
+                </a:path>
+              </a:pathLst>
+            </a:custGeom>
+            <a:solidFill>
+              <a:srgbClr val="0571D3"/>
+            </a:solidFill>
+            <a:ln cap="sq">
+              <a:noFill/>
+              <a:prstDash val="solid"/>
+              <a:miter/>
+            </a:ln>
+          </p:spPr>
+        </p:sp>
+      </p:grpSp>
+      <p:grpSp>
+        <p:nvGrpSpPr>
+          <p:cNvPr name="Group 11" id="11"/>
+          <p:cNvGrpSpPr/>
+          <p:nvPr/>
+        </p:nvGrpSpPr>
+        <p:grpSpPr>
+          <a:xfrm rot="0">
+            <a:off x="12552045" y="9381172"/>
+            <a:ext cx="2976562" cy="193358"/>
+            <a:chOff x="0" y="0"/>
+            <a:chExt cx="3968750" cy="257810"/>
+          </a:xfrm>
+        </p:grpSpPr>
+        <p:sp>
+          <p:nvSpPr>
+            <p:cNvPr name="Freeform 12" id="12"/>
+            <p:cNvSpPr/>
+            <p:nvPr/>
+          </p:nvSpPr>
+          <p:spPr>
+            <a:xfrm flipH="false" flipV="false" rot="0">
+              <a:off x="50800" y="35722"/>
+              <a:ext cx="3867650" cy="200662"/>
+            </a:xfrm>
+            <a:custGeom>
+              <a:avLst/>
+              <a:gdLst/>
+              <a:ahLst/>
+              <a:cxnLst/>
+              <a:rect r="r" b="b" t="t" l="l"/>
+              <a:pathLst>
+                <a:path h="200662" w="3867650">
+                  <a:moveTo>
+                    <a:pt x="25400" y="120488"/>
+                  </a:moveTo>
+                  <a:cubicBezTo>
+                    <a:pt x="1532890" y="98898"/>
+                    <a:pt x="1624330" y="39208"/>
+                    <a:pt x="1859280" y="17618"/>
+                  </a:cubicBezTo>
+                  <a:cubicBezTo>
+                    <a:pt x="2270760" y="-20482"/>
+                    <a:pt x="3375660" y="15078"/>
+                    <a:pt x="3566160" y="15078"/>
+                  </a:cubicBezTo>
+                  <a:cubicBezTo>
+                    <a:pt x="3604260" y="15078"/>
+                    <a:pt x="3608070" y="8728"/>
+                    <a:pt x="3634740" y="15078"/>
+                  </a:cubicBezTo>
+                  <a:cubicBezTo>
+                    <a:pt x="3677920" y="23968"/>
+                    <a:pt x="3756660" y="63338"/>
+                    <a:pt x="3798570" y="87468"/>
+                  </a:cubicBezTo>
+                  <a:cubicBezTo>
+                    <a:pt x="3827780" y="103978"/>
+                    <a:pt x="3860800" y="120488"/>
+                    <a:pt x="3865880" y="136998"/>
+                  </a:cubicBezTo>
+                  <a:cubicBezTo>
+                    <a:pt x="3869690" y="147158"/>
+                    <a:pt x="3863340" y="161128"/>
+                    <a:pt x="3856990" y="166208"/>
+                  </a:cubicBezTo>
+                  <a:cubicBezTo>
+                    <a:pt x="3850640" y="171288"/>
+                    <a:pt x="3831590" y="170018"/>
+                    <a:pt x="3826510" y="164938"/>
+                  </a:cubicBezTo>
+                  <a:cubicBezTo>
+                    <a:pt x="3820160" y="158588"/>
+                    <a:pt x="3818890" y="135728"/>
+                    <a:pt x="3823970" y="128108"/>
+                  </a:cubicBezTo>
+                  <a:cubicBezTo>
+                    <a:pt x="3827780" y="121758"/>
+                    <a:pt x="3839210" y="119218"/>
+                    <a:pt x="3846830" y="120488"/>
+                  </a:cubicBezTo>
+                  <a:cubicBezTo>
+                    <a:pt x="3853180" y="121758"/>
+                    <a:pt x="3862070" y="128108"/>
+                    <a:pt x="3865880" y="134458"/>
+                  </a:cubicBezTo>
+                  <a:cubicBezTo>
+                    <a:pt x="3868420" y="140808"/>
+                    <a:pt x="3868420" y="152238"/>
+                    <a:pt x="3864610" y="158588"/>
+                  </a:cubicBezTo>
+                  <a:cubicBezTo>
+                    <a:pt x="3860800" y="163668"/>
+                    <a:pt x="3854450" y="170018"/>
+                    <a:pt x="3844290" y="171288"/>
+                  </a:cubicBezTo>
+                  <a:cubicBezTo>
+                    <a:pt x="3811270" y="172558"/>
+                    <a:pt x="3742690" y="91278"/>
+                    <a:pt x="3633470" y="65878"/>
+                  </a:cubicBezTo>
+                  <a:cubicBezTo>
+                    <a:pt x="3335020" y="-5242"/>
+                    <a:pt x="2287270" y="29048"/>
+                    <a:pt x="1864360" y="68418"/>
+                  </a:cubicBezTo>
+                  <a:cubicBezTo>
+                    <a:pt x="1626870" y="90008"/>
+                    <a:pt x="1534160" y="149698"/>
+                    <a:pt x="1310640" y="171288"/>
+                  </a:cubicBezTo>
+                  <a:cubicBezTo>
+                    <a:pt x="971550" y="201768"/>
+                    <a:pt x="129540" y="218278"/>
+                    <a:pt x="25400" y="171288"/>
+                  </a:cubicBezTo>
+                  <a:cubicBezTo>
+                    <a:pt x="7620" y="162398"/>
+                    <a:pt x="0" y="150968"/>
+                    <a:pt x="0" y="142078"/>
+                  </a:cubicBezTo>
+                  <a:cubicBezTo>
+                    <a:pt x="0" y="134458"/>
+                    <a:pt x="25400" y="120488"/>
+                    <a:pt x="25400" y="120488"/>
+                  </a:cubicBezTo>
+                </a:path>
+              </a:pathLst>
+            </a:custGeom>
+            <a:solidFill>
+              <a:srgbClr val="0571D3"/>
+            </a:solidFill>
+            <a:ln cap="sq">
+              <a:noFill/>
+              <a:prstDash val="solid"/>
+              <a:miter/>
+            </a:ln>
+          </p:spPr>
+        </p:sp>
+      </p:grpSp>
+    </p:spTree>
+  </p:cSld>
+  <p:clrMapOvr>
+    <a:masterClrMapping/>
+  </p:clrMapOvr>
+</p:sld>
+</file>
+
+<file path=ppt/slides/slide6.xml><?xml version="1.0" encoding="utf-8"?>
+<p:sld xmlns:p="http://schemas.openxmlformats.org/presentationml/2006/main" xmlns:a="http://schemas.openxmlformats.org/drawingml/2006/main" xmlns:r="http://schemas.openxmlformats.org/officeDocument/2006/relationships">
+  <p:cSld>
+    <p:spTree>
+      <p:nvGrpSpPr>
+        <p:cNvPr id="1" name=""/>
+        <p:cNvGrpSpPr/>
+        <p:nvPr/>
+      </p:nvGrpSpPr>
+      <p:grpSpPr>
+        <a:xfrm>
+          <a:off x="0" y="0"/>
+          <a:ext cx="0" cy="0"/>
+          <a:chOff x="0" y="0"/>
+          <a:chExt cx="0" cy="0"/>
+        </a:xfrm>
+      </p:grpSpPr>
+      <p:sp>
+        <p:nvSpPr>
+          <p:cNvPr name="Freeform 2" id="2"/>
+          <p:cNvSpPr/>
+          <p:nvPr/>
+        </p:nvSpPr>
+        <p:spPr>
+          <a:xfrm flipH="false" flipV="false" rot="0">
             <a:off x="8155325" y="2459303"/>
             <a:ext cx="9752350" cy="6798997"/>
           </a:xfrm>
@@ -7814,7 +8985,7 @@
 </p:sld>
 </file>
 
-<file path=ppt/slides/slide6.xml><?xml version="1.0" encoding="utf-8"?>
+<file path=ppt/slides/slide7.xml><?xml version="1.0" encoding="utf-8"?>
 <p:sld xmlns:p="http://schemas.openxmlformats.org/presentationml/2006/main" xmlns:a="http://schemas.openxmlformats.org/drawingml/2006/main" xmlns:r="http://schemas.openxmlformats.org/officeDocument/2006/relationships">
   <p:cSld>
     <p:spTree>
@@ -8163,7 +9334,7 @@
 </p:sld>
 </file>
 
-<file path=ppt/slides/slide7.xml><?xml version="1.0" encoding="utf-8"?>
+<file path=ppt/slides/slide8.xml><?xml version="1.0" encoding="utf-8"?>
 <p:sld xmlns:p="http://schemas.openxmlformats.org/presentationml/2006/main" xmlns:a="http://schemas.openxmlformats.org/drawingml/2006/main" xmlns:r="http://schemas.openxmlformats.org/officeDocument/2006/relationships">
   <p:cSld>
     <p:spTree>
@@ -8512,7 +9683,7 @@
 </p:sld>
 </file>
 
-<file path=ppt/slides/slide8.xml><?xml version="1.0" encoding="utf-8"?>
+<file path=ppt/slides/slide9.xml><?xml version="1.0" encoding="utf-8"?>
 <p:sld xmlns:p="http://schemas.openxmlformats.org/presentationml/2006/main" xmlns:a="http://schemas.openxmlformats.org/drawingml/2006/main" xmlns:r="http://schemas.openxmlformats.org/officeDocument/2006/relationships">
   <p:cSld>
     <p:spTree>
@@ -8732,383 +9903,6 @@
                 <a:sym typeface="Canva Sans"/>
               </a:rPr>
               <a:t>Dims of b1 ⟶ (1, 128)</a:t>
-            </a:r>
-          </a:p>
-        </p:txBody>
-      </p:sp>
-    </p:spTree>
-  </p:cSld>
-  <p:clrMapOvr>
-    <a:masterClrMapping/>
-  </p:clrMapOvr>
-</p:sld>
-</file>
-
-<file path=ppt/slides/slide9.xml><?xml version="1.0" encoding="utf-8"?>
-<p:sld xmlns:p="http://schemas.openxmlformats.org/presentationml/2006/main" xmlns:a="http://schemas.openxmlformats.org/drawingml/2006/main" xmlns:r="http://schemas.openxmlformats.org/officeDocument/2006/relationships">
-  <p:cSld>
-    <p:spTree>
-      <p:nvGrpSpPr>
-        <p:cNvPr id="1" name=""/>
-        <p:cNvGrpSpPr/>
-        <p:nvPr/>
-      </p:nvGrpSpPr>
-      <p:grpSpPr>
-        <a:xfrm>
-          <a:off x="0" y="0"/>
-          <a:ext cx="0" cy="0"/>
-          <a:chOff x="0" y="0"/>
-          <a:chExt cx="0" cy="0"/>
-        </a:xfrm>
-      </p:grpSpPr>
-      <p:sp>
-        <p:nvSpPr>
-          <p:cNvPr name="Freeform 2" id="2"/>
-          <p:cNvSpPr/>
-          <p:nvPr/>
-        </p:nvSpPr>
-        <p:spPr>
-          <a:xfrm flipH="false" flipV="false" rot="0">
-            <a:off x="10238752" y="3259167"/>
-            <a:ext cx="7401946" cy="6450267"/>
-          </a:xfrm>
-          <a:custGeom>
-            <a:avLst/>
-            <a:gdLst/>
-            <a:ahLst/>
-            <a:cxnLst/>
-            <a:rect r="r" b="b" t="t" l="l"/>
-            <a:pathLst>
-              <a:path h="6450267" w="7401946">
-                <a:moveTo>
-                  <a:pt x="0" y="0"/>
-                </a:moveTo>
-                <a:lnTo>
-                  <a:pt x="7401945" y="0"/>
-                </a:lnTo>
-                <a:lnTo>
-                  <a:pt x="7401945" y="6450267"/>
-                </a:lnTo>
-                <a:lnTo>
-                  <a:pt x="0" y="6450267"/>
-                </a:lnTo>
-                <a:lnTo>
-                  <a:pt x="0" y="0"/>
-                </a:lnTo>
-                <a:close/>
-              </a:path>
-            </a:pathLst>
-          </a:custGeom>
-          <a:blipFill>
-            <a:blip r:embed="rId2"/>
-            <a:stretch>
-              <a:fillRect l="0" t="0" r="0" b="0"/>
-            </a:stretch>
-          </a:blipFill>
-        </p:spPr>
-      </p:sp>
-      <p:sp>
-        <p:nvSpPr>
-          <p:cNvPr name="TextBox 3" id="3"/>
-          <p:cNvSpPr txBox="true"/>
-          <p:nvPr/>
-        </p:nvSpPr>
-        <p:spPr>
-          <a:xfrm rot="0">
-            <a:off x="1238848" y="375983"/>
-            <a:ext cx="16020452" cy="2432050"/>
-          </a:xfrm>
-          <a:prstGeom prst="rect">
-            <a:avLst/>
-          </a:prstGeom>
-        </p:spPr>
-        <p:txBody>
-          <a:bodyPr anchor="t" rtlCol="false" tIns="0" lIns="0" bIns="0" rIns="0">
-            <a:spAutoFit/>
-          </a:bodyPr>
-          <a:lstStyle/>
-          <a:p>
-            <a:pPr algn="ctr">
-              <a:lnSpc>
-                <a:spcPts val="9799"/>
-              </a:lnSpc>
-            </a:pPr>
-            <a:r>
-              <a:rPr lang="en-US" sz="6999" b="true">
-                <a:solidFill>
-                  <a:srgbClr val="000000"/>
-                </a:solidFill>
-                <a:latin typeface="Canva Sans Bold"/>
-                <a:ea typeface="Canva Sans Bold"/>
-                <a:cs typeface="Canva Sans Bold"/>
-                <a:sym typeface="Canva Sans Bold"/>
-              </a:rPr>
-              <a:t>Dimension of weights and bias matrix in each layer</a:t>
-            </a:r>
-          </a:p>
-        </p:txBody>
-      </p:sp>
-      <p:sp>
-        <p:nvSpPr>
-          <p:cNvPr name="TextBox 4" id="4"/>
-          <p:cNvSpPr txBox="true"/>
-          <p:nvPr/>
-        </p:nvSpPr>
-        <p:spPr>
-          <a:xfrm rot="0">
-            <a:off x="1238848" y="3294378"/>
-            <a:ext cx="8187184" cy="1780540"/>
-          </a:xfrm>
-          <a:prstGeom prst="rect">
-            <a:avLst/>
-          </a:prstGeom>
-        </p:spPr>
-        <p:txBody>
-          <a:bodyPr anchor="t" rtlCol="false" tIns="0" lIns="0" bIns="0" rIns="0">
-            <a:spAutoFit/>
-          </a:bodyPr>
-          <a:lstStyle/>
-          <a:p>
-            <a:pPr algn="l">
-              <a:lnSpc>
-                <a:spcPts val="4759"/>
-              </a:lnSpc>
-            </a:pPr>
-            <a:r>
-              <a:rPr lang="en-US" sz="3399">
-                <a:solidFill>
-                  <a:srgbClr val="000000"/>
-                </a:solidFill>
-                <a:latin typeface="Canva Sans"/>
-                <a:ea typeface="Canva Sans"/>
-                <a:cs typeface="Canva Sans"/>
-                <a:sym typeface="Canva Sans"/>
-              </a:rPr>
-              <a:t>Weights and bias matrix could be found</a:t>
-            </a:r>
-          </a:p>
-          <a:p>
-            <a:pPr algn="l">
-              <a:lnSpc>
-                <a:spcPts val="4759"/>
-              </a:lnSpc>
-            </a:pPr>
-            <a:r>
-              <a:rPr lang="en-US" sz="3399">
-                <a:solidFill>
-                  <a:srgbClr val="000000"/>
-                </a:solidFill>
-                <a:latin typeface="Canva Sans"/>
-                <a:ea typeface="Canva Sans"/>
-                <a:cs typeface="Canva Sans"/>
-                <a:sym typeface="Canva Sans"/>
-              </a:rPr>
-              <a:t>by following the trends in the last two</a:t>
-            </a:r>
-          </a:p>
-          <a:p>
-            <a:pPr algn="l">
-              <a:lnSpc>
-                <a:spcPts val="4759"/>
-              </a:lnSpc>
-            </a:pPr>
-            <a:r>
-              <a:rPr lang="en-US" sz="3399">
-                <a:solidFill>
-                  <a:srgbClr val="000000"/>
-                </a:solidFill>
-                <a:latin typeface="Canva Sans"/>
-                <a:ea typeface="Canva Sans"/>
-                <a:cs typeface="Canva Sans"/>
-                <a:sym typeface="Canva Sans"/>
-              </a:rPr>
-              <a:t>slides.</a:t>
-            </a:r>
-          </a:p>
-        </p:txBody>
-      </p:sp>
-      <p:sp>
-        <p:nvSpPr>
-          <p:cNvPr name="TextBox 5" id="5"/>
-          <p:cNvSpPr txBox="true"/>
-          <p:nvPr/>
-        </p:nvSpPr>
-        <p:spPr>
-          <a:xfrm rot="0">
-            <a:off x="1238848" y="5560693"/>
-            <a:ext cx="7875389" cy="1780540"/>
-          </a:xfrm>
-          <a:prstGeom prst="rect">
-            <a:avLst/>
-          </a:prstGeom>
-        </p:spPr>
-        <p:txBody>
-          <a:bodyPr anchor="t" rtlCol="false" tIns="0" lIns="0" bIns="0" rIns="0">
-            <a:spAutoFit/>
-          </a:bodyPr>
-          <a:lstStyle/>
-          <a:p>
-            <a:pPr algn="l">
-              <a:lnSpc>
-                <a:spcPts val="4759"/>
-              </a:lnSpc>
-            </a:pPr>
-            <a:r>
-              <a:rPr lang="en-US" sz="3399">
-                <a:solidFill>
-                  <a:srgbClr val="000000"/>
-                </a:solidFill>
-                <a:latin typeface="Canva Sans"/>
-                <a:ea typeface="Canva Sans"/>
-                <a:cs typeface="Canva Sans"/>
-                <a:sym typeface="Canva Sans"/>
-              </a:rPr>
-              <a:t>One observable point is that for every</a:t>
-            </a:r>
-          </a:p>
-          <a:p>
-            <a:pPr algn="l" marL="734059" indent="-367030" lvl="1">
-              <a:lnSpc>
-                <a:spcPts val="4759"/>
-              </a:lnSpc>
-              <a:buAutoNum type="arabicPeriod" startAt="1"/>
-            </a:pPr>
-            <a:r>
-              <a:rPr lang="en-US" sz="3399">
-                <a:solidFill>
-                  <a:srgbClr val="000000"/>
-                </a:solidFill>
-                <a:latin typeface="Canva Sans"/>
-                <a:ea typeface="Canva Sans"/>
-                <a:cs typeface="Canva Sans"/>
-                <a:sym typeface="Canva Sans"/>
-              </a:rPr>
-              <a:t>Weight matrix ⟶ (n_in, n_out)</a:t>
-            </a:r>
-          </a:p>
-          <a:p>
-            <a:pPr algn="l" marL="734059" indent="-367030" lvl="1">
-              <a:lnSpc>
-                <a:spcPts val="4759"/>
-              </a:lnSpc>
-              <a:buAutoNum type="arabicPeriod" startAt="1"/>
-            </a:pPr>
-            <a:r>
-              <a:rPr lang="en-US" sz="3399">
-                <a:solidFill>
-                  <a:srgbClr val="000000"/>
-                </a:solidFill>
-                <a:latin typeface="Canva Sans"/>
-                <a:ea typeface="Canva Sans"/>
-                <a:cs typeface="Canva Sans"/>
-                <a:sym typeface="Canva Sans"/>
-              </a:rPr>
-              <a:t>Bias matrix ⟶ (1, n_out)</a:t>
-            </a:r>
-          </a:p>
-        </p:txBody>
-      </p:sp>
-      <p:sp>
-        <p:nvSpPr>
-          <p:cNvPr name="TextBox 6" id="6"/>
-          <p:cNvSpPr txBox="true"/>
-          <p:nvPr/>
-        </p:nvSpPr>
-        <p:spPr>
-          <a:xfrm rot="0">
-            <a:off x="1238848" y="7607695"/>
-            <a:ext cx="7473925" cy="2184399"/>
-          </a:xfrm>
-          <a:prstGeom prst="rect">
-            <a:avLst/>
-          </a:prstGeom>
-        </p:spPr>
-        <p:txBody>
-          <a:bodyPr anchor="t" rtlCol="false" tIns="0" lIns="0" bIns="0" rIns="0">
-            <a:spAutoFit/>
-          </a:bodyPr>
-          <a:lstStyle/>
-          <a:p>
-            <a:pPr algn="l">
-              <a:lnSpc>
-                <a:spcPts val="3500"/>
-              </a:lnSpc>
-            </a:pPr>
-            <a:r>
-              <a:rPr lang="en-US" sz="2500">
-                <a:solidFill>
-                  <a:srgbClr val="000000"/>
-                </a:solidFill>
-                <a:latin typeface="Canva Sans"/>
-                <a:ea typeface="Canva Sans"/>
-                <a:cs typeface="Canva Sans"/>
-                <a:sym typeface="Canva Sans"/>
-              </a:rPr>
-              <a:t>where n_in = number of inputs for layer (or)</a:t>
-            </a:r>
-          </a:p>
-          <a:p>
-            <a:pPr algn="l">
-              <a:lnSpc>
-                <a:spcPts val="3500"/>
-              </a:lnSpc>
-            </a:pPr>
-            <a:r>
-              <a:rPr lang="en-US" sz="2500">
-                <a:solidFill>
-                  <a:srgbClr val="000000"/>
-                </a:solidFill>
-                <a:latin typeface="Canva Sans"/>
-                <a:ea typeface="Canva Sans"/>
-                <a:cs typeface="Canva Sans"/>
-                <a:sym typeface="Canva Sans"/>
-              </a:rPr>
-              <a:t>                         number of neurons in previous layer</a:t>
-            </a:r>
-          </a:p>
-          <a:p>
-            <a:pPr algn="l">
-              <a:lnSpc>
-                <a:spcPts val="3500"/>
-              </a:lnSpc>
-            </a:pPr>
-          </a:p>
-          <a:p>
-            <a:pPr algn="l">
-              <a:lnSpc>
-                <a:spcPts val="3500"/>
-              </a:lnSpc>
-            </a:pPr>
-            <a:r>
-              <a:rPr lang="en-US" sz="2500">
-                <a:solidFill>
-                  <a:srgbClr val="000000"/>
-                </a:solidFill>
-                <a:latin typeface="Canva Sans"/>
-                <a:ea typeface="Canva Sans"/>
-                <a:cs typeface="Canva Sans"/>
-                <a:sym typeface="Canva Sans"/>
-              </a:rPr>
-              <a:t>n_out = number of outputs by layer (or)</a:t>
-            </a:r>
-          </a:p>
-          <a:p>
-            <a:pPr algn="l">
-              <a:lnSpc>
-                <a:spcPts val="3500"/>
-              </a:lnSpc>
-            </a:pPr>
-            <a:r>
-              <a:rPr lang="en-US" sz="2500">
-                <a:solidFill>
-                  <a:srgbClr val="000000"/>
-                </a:solidFill>
-                <a:latin typeface="Canva Sans"/>
-                <a:ea typeface="Canva Sans"/>
-                <a:cs typeface="Canva Sans"/>
-                <a:sym typeface="Canva Sans"/>
-              </a:rPr>
-              <a:t>               number of neurons in current layer</a:t>
             </a:r>
           </a:p>
         </p:txBody>

</xml_diff>